<commit_message>
Update DGE deck with Insee card-payment data, border typology and new sources
Co-Authored-By: Claude Opus 5.5 <noreply@anthropic.com>
Claude-Session: https://claude.ai/code/session_01FJbXnypcpDe1GWB1d6YYfb
</commit_message>
<xml_diff>
--- a/cross_border/report_docx/Commerce_detail_France_DGE_DGGROW_7slides.pptx
+++ b/cross_border/report_docx/Commerce_detail_France_DGE_DGGROW_7slides.pptx
@@ -2163,7 +2163,7 @@
               <a:lstStyle/>
               <a:p>
                 <a:pPr>
-                  <a:defRPr b="1" i="0" strike="noStrike" sz="1100" u="none">
+                  <a:defRPr b="1" i="0" strike="noStrike" sz="1000" u="none">
                     <a:solidFill>
                       <a:srgbClr val="404040"/>
                     </a:solidFill>
@@ -2180,95 +2180,47 @@
             <c:showBubbleSize val="0"/>
             <c:showLeaderLines val="0"/>
           </c:dLbls>
-          <c:dPt>
-            <c:idx val="0"/>
-            <c:invertIfNegative val="0"/>
-            <c:bubble3D val="0"/>
-            <c:spPr>
-              <a:solidFill>
-                <a:srgbClr val="003087"/>
-              </a:solidFill>
-              <a:effectLst/>
-            </c:spPr>
-          </c:dPt>
-          <c:dPt>
-            <c:idx val="1"/>
-            <c:invertIfNegative val="0"/>
-            <c:bubble3D val="0"/>
-            <c:spPr>
-              <a:solidFill>
-                <a:srgbClr val="003087"/>
-              </a:solidFill>
-              <a:effectLst/>
-            </c:spPr>
-          </c:dPt>
-          <c:dPt>
-            <c:idx val="2"/>
-            <c:invertIfNegative val="0"/>
-            <c:bubble3D val="0"/>
-            <c:spPr>
-              <a:solidFill>
-                <a:srgbClr val="003087"/>
-              </a:solidFill>
-              <a:effectLst/>
-            </c:spPr>
-          </c:dPt>
-          <c:dPt>
-            <c:idx val="3"/>
-            <c:invertIfNegative val="0"/>
-            <c:bubble3D val="0"/>
-            <c:spPr>
-              <a:solidFill>
-                <a:srgbClr val="8DB9E2"/>
-              </a:solidFill>
-              <a:effectLst/>
-            </c:spPr>
-          </c:dPt>
-          <c:dPt>
-            <c:idx val="4"/>
-            <c:invertIfNegative val="0"/>
-            <c:bubble3D val="0"/>
-            <c:spPr>
-              <a:solidFill>
-                <a:srgbClr val="0070C0"/>
-              </a:solidFill>
-              <a:effectLst/>
-            </c:spPr>
-          </c:dPt>
-          <c:dPt>
-            <c:idx val="5"/>
-            <c:invertIfNegative val="0"/>
-            <c:bubble3D val="0"/>
-            <c:spPr>
-              <a:solidFill>
-                <a:srgbClr val="B4BCC6"/>
-              </a:solidFill>
-              <a:effectLst/>
-            </c:spPr>
-          </c:dPt>
           <c:cat>
             <c:multiLvlStrRef>
-              <c:f>Sheet1!$A$2:$A$7</c:f>
+              <c:f>Sheet1!$A$2:$A$13</c:f>
               <c:multiLvlStrCache>
-                <c:ptCount val="6"/>
+                <c:ptCount val="12"/>
                 <c:lvl>
                   <c:pt idx="0">
-                    <c:v>Frontière Allemagne–Luxembourg</c:v>
+                    <c:v>Moselle (LU, DE)</c:v>
                   </c:pt>
                   <c:pt idx="1">
-                    <c:v>Frontière Espagne–Andorre</c:v>
+                    <c:v>Pyrénées-Orientales (ES, AD)</c:v>
                   </c:pt>
                   <c:pt idx="2">
-                    <c:v>Frontière belge</c:v>
+                    <c:v>Meurthe-et-Moselle (BE, LU)</c:v>
                   </c:pt>
                   <c:pt idx="3">
-                    <c:v>Frontière suisse</c:v>
+                    <c:v>Haut-Rhin (DE, CH)</c:v>
                   </c:pt>
                   <c:pt idx="4">
-                    <c:v>Ensemble des départements frontaliers</c:v>
+                    <c:v>Haute-Savoie (CH, IT)</c:v>
                   </c:pt>
                   <c:pt idx="5">
-                    <c:v>Reste de la France</c:v>
+                    <c:v>Pyrénées-Atlantiques (ES)</c:v>
+                  </c:pt>
+                  <c:pt idx="6">
+                    <c:v>Bas-Rhin (DE)</c:v>
+                  </c:pt>
+                  <c:pt idx="7">
+                    <c:v>Ardennes (BE)</c:v>
+                  </c:pt>
+                  <c:pt idx="8">
+                    <c:v>Nord (BE)</c:v>
+                  </c:pt>
+                  <c:pt idx="9">
+                    <c:v>Ain (CH)</c:v>
+                  </c:pt>
+                  <c:pt idx="10">
+                    <c:v>Alpes-Maritimes (IT, MC)</c:v>
+                  </c:pt>
+                  <c:pt idx="11">
+                    <c:v>Ariège (ES, AD)</c:v>
                   </c:pt>
                 </c:lvl>
               </c:multiLvlStrCache>
@@ -2276,27 +2228,45 @@
           </c:cat>
           <c:val>
             <c:numRef>
-              <c:f>Sheet1!$B$2:$B$7</c:f>
+              <c:f>Sheet1!$B$2:$B$13</c:f>
               <c:numCache>
                 <c:formatCode>General</c:formatCode>
-                <c:ptCount val="6"/>
+                <c:ptCount val="12"/>
                 <c:pt idx="0">
-                  <c:v>44.6</c:v>
+                  <c:v>13.9</c:v>
                 </c:pt>
                 <c:pt idx="1">
-                  <c:v>44.5</c:v>
+                  <c:v>12</c:v>
                 </c:pt>
                 <c:pt idx="2">
-                  <c:v>28.8</c:v>
+                  <c:v>9.5</c:v>
                 </c:pt>
                 <c:pt idx="3">
-                  <c:v>2.6</c:v>
+                  <c:v>8.8</c:v>
                 </c:pt>
                 <c:pt idx="4">
-                  <c:v>21.9</c:v>
+                  <c:v>8.7</c:v>
                 </c:pt>
                 <c:pt idx="5">
-                  <c:v>2.4</c:v>
+                  <c:v>8.4</c:v>
+                </c:pt>
+                <c:pt idx="6">
+                  <c:v>7.8</c:v>
+                </c:pt>
+                <c:pt idx="7">
+                  <c:v>7.7</c:v>
+                </c:pt>
+                <c:pt idx="8">
+                  <c:v>7</c:v>
+                </c:pt>
+                <c:pt idx="9">
+                  <c:v>7</c:v>
+                </c:pt>
+                <c:pt idx="10">
+                  <c:v>6.4</c:v>
+                </c:pt>
+                <c:pt idx="11">
+                  <c:v>5.9</c:v>
                 </c:pt>
               </c:numCache>
             </c:numRef>
@@ -2309,7 +2279,7 @@
             <a:lstStyle/>
             <a:p>
               <a:pPr>
-                <a:defRPr b="1" i="0" strike="noStrike" sz="1100" u="none">
+                <a:defRPr b="1" i="0" strike="noStrike" sz="1000" u="none">
                   <a:solidFill>
                     <a:srgbClr val="404040"/>
                   </a:solidFill>
@@ -2326,7 +2296,7 @@
           <c:showBubbleSize val="0"/>
           <c:showLeaderLines val="0"/>
         </c:dLbls>
-        <c:gapWidth val="45"/>
+        <c:gapWidth val="35"/>
         <c:overlap val="0"/>
         <c:axId val="2094734554"/>
         <c:axId val="2094734552"/>
@@ -2357,7 +2327,7 @@
           <a:lstStyle/>
           <a:p>
             <a:pPr>
-              <a:defRPr sz="1100" b="0" i="0" u="none" strike="noStrike">
+              <a:defRPr sz="1000" b="0" i="0" u="none" strike="noStrike">
                 <a:solidFill>
                   <a:srgbClr val="404040"/>
                 </a:solidFill>
@@ -2377,7 +2347,7 @@
         <c:axId val="2094734552"/>
         <c:scaling>
           <c:orientation val="minMax"/>
-          <c:max val="52"/>
+          <c:max val="16"/>
           <c:min val="0"/>
         </c:scaling>
         <c:delete val="1"/>
@@ -2439,321 +2409,6 @@
 </file>
 
 <file path=ppt/charts/chart5.xml><?xml version="1.0" encoding="utf-8"?>
-<c:chartSpace xmlns:c="http://schemas.openxmlformats.org/drawingml/2006/chart" xmlns:a="http://schemas.openxmlformats.org/drawingml/2006/main" xmlns:r="http://schemas.openxmlformats.org/officeDocument/2006/relationships">
-  <c:date1904 val="0"/>
-  <c:roundedCorners val="1"/>
-  <c:chart>
-    <c:autoTitleDeleted val="1"/>
-    <c:plotArea>
-      <c:layout/>
-      <c:barChart>
-        <c:barDir val="bar"/>
-        <c:grouping val="clustered"/>
-        <c:varyColors val="0"/>
-        <c:ser>
-          <c:idx val="0"/>
-          <c:order val="0"/>
-          <c:tx>
-            <c:strRef>
-              <c:f>Sheet1!$B$1</c:f>
-              <c:strCache>
-                <c:ptCount val="1"/>
-                <c:pt idx="0">
-                  <c:v>%</c:v>
-                </c:pt>
-              </c:strCache>
-            </c:strRef>
-          </c:tx>
-          <c:spPr>
-            <a:solidFill>
-              <a:srgbClr val="0070C0"/>
-            </a:solidFill>
-            <a:effectLst/>
-          </c:spPr>
-          <c:invertIfNegative val="0"/>
-          <c:dLbls>
-            <c:numFmt formatCode="+0;-0" sourceLinked="0"/>
-            <c:txPr>
-              <a:bodyPr/>
-              <a:lstStyle/>
-              <a:p>
-                <a:pPr>
-                  <a:defRPr b="1" i="0" strike="noStrike" sz="1100" u="none">
-                    <a:solidFill>
-                      <a:srgbClr val="404040"/>
-                    </a:solidFill>
-                    <a:latin typeface="Arial"/>
-                  </a:defRPr>
-                </a:pPr>
-              </a:p>
-            </c:txPr>
-            <c:showLegendKey val="0"/>
-            <c:showVal val="1"/>
-            <c:showCatName val="0"/>
-            <c:showSerName val="0"/>
-            <c:showPercent val="0"/>
-            <c:showBubbleSize val="0"/>
-            <c:showLeaderLines val="0"/>
-          </c:dLbls>
-          <c:dPt>
-            <c:idx val="0"/>
-            <c:invertIfNegative val="0"/>
-            <c:bubble3D val="0"/>
-            <c:spPr>
-              <a:solidFill>
-                <a:srgbClr val="0070C0"/>
-              </a:solidFill>
-              <a:effectLst/>
-            </c:spPr>
-          </c:dPt>
-          <c:dPt>
-            <c:idx val="1"/>
-            <c:invertIfNegative val="0"/>
-            <c:bubble3D val="0"/>
-            <c:spPr>
-              <a:solidFill>
-                <a:srgbClr val="0070C0"/>
-              </a:solidFill>
-              <a:effectLst/>
-            </c:spPr>
-          </c:dPt>
-          <c:dPt>
-            <c:idx val="2"/>
-            <c:invertIfNegative val="0"/>
-            <c:bubble3D val="0"/>
-            <c:spPr>
-              <a:solidFill>
-                <a:srgbClr val="D9822B"/>
-              </a:solidFill>
-              <a:effectLst/>
-            </c:spPr>
-          </c:dPt>
-          <c:dPt>
-            <c:idx val="3"/>
-            <c:invertIfNegative val="0"/>
-            <c:bubble3D val="0"/>
-            <c:spPr>
-              <a:solidFill>
-                <a:srgbClr val="D9822B"/>
-              </a:solidFill>
-              <a:effectLst/>
-            </c:spPr>
-          </c:dPt>
-          <c:dPt>
-            <c:idx val="4"/>
-            <c:invertIfNegative val="0"/>
-            <c:bubble3D val="0"/>
-            <c:spPr>
-              <a:solidFill>
-                <a:srgbClr val="D9822B"/>
-              </a:solidFill>
-              <a:effectLst/>
-            </c:spPr>
-          </c:dPt>
-          <c:dPt>
-            <c:idx val="5"/>
-            <c:invertIfNegative val="0"/>
-            <c:bubble3D val="0"/>
-            <c:spPr>
-              <a:solidFill>
-                <a:srgbClr val="D9822B"/>
-              </a:solidFill>
-              <a:effectLst/>
-            </c:spPr>
-          </c:dPt>
-          <c:cat>
-            <c:multiLvlStrRef>
-              <c:f>Sheet1!$A$2:$A$7</c:f>
-              <c:multiLvlStrCache>
-                <c:ptCount val="6"/>
-                <c:lvl>
-                  <c:pt idx="0">
-                    <c:v>Super et hypermarchés</c:v>
-                  </c:pt>
-                  <c:pt idx="1">
-                    <c:v>Commerces de détail</c:v>
-                  </c:pt>
-                  <c:pt idx="2">
-                    <c:v>Stations-service</c:v>
-                  </c:pt>
-                  <c:pt idx="3">
-                    <c:v>Buralistes</c:v>
-                  </c:pt>
-                  <c:pt idx="4">
-                    <c:v>Stations-service, frontière luxembourgeoise</c:v>
-                  </c:pt>
-                  <c:pt idx="5">
-                    <c:v>Buralistes, frontière luxembourgeoise</c:v>
-                  </c:pt>
-                </c:lvl>
-              </c:multiLvlStrCache>
-            </c:multiLvlStrRef>
-          </c:cat>
-          <c:val>
-            <c:numRef>
-              <c:f>Sheet1!$B$2:$B$7</c:f>
-              <c:numCache>
-                <c:formatCode>General</c:formatCode>
-                <c:ptCount val="6"/>
-                <c:pt idx="0">
-                  <c:v>6</c:v>
-                </c:pt>
-                <c:pt idx="1">
-                  <c:v>-2</c:v>
-                </c:pt>
-                <c:pt idx="2">
-                  <c:v>-17</c:v>
-                </c:pt>
-                <c:pt idx="3">
-                  <c:v>-25</c:v>
-                </c:pt>
-                <c:pt idx="4">
-                  <c:v>-57</c:v>
-                </c:pt>
-                <c:pt idx="5">
-                  <c:v>-64</c:v>
-                </c:pt>
-              </c:numCache>
-            </c:numRef>
-          </c:val>
-        </c:ser>
-        <c:dLbls>
-          <c:numFmt formatCode="+0;-0" sourceLinked="0"/>
-          <c:txPr>
-            <a:bodyPr/>
-            <a:lstStyle/>
-            <a:p>
-              <a:pPr>
-                <a:defRPr b="1" i="0" strike="noStrike" sz="1100" u="none">
-                  <a:solidFill>
-                    <a:srgbClr val="404040"/>
-                  </a:solidFill>
-                  <a:latin typeface="Arial"/>
-                </a:defRPr>
-              </a:pPr>
-            </a:p>
-          </c:txPr>
-          <c:showLegendKey val="0"/>
-          <c:showVal val="1"/>
-          <c:showCatName val="0"/>
-          <c:showSerName val="0"/>
-          <c:showPercent val="0"/>
-          <c:showBubbleSize val="0"/>
-          <c:showLeaderLines val="0"/>
-        </c:dLbls>
-        <c:gapWidth val="40"/>
-        <c:overlap val="0"/>
-        <c:axId val="2094734554"/>
-        <c:axId val="2094734552"/>
-        <c:axId val="2094734556"/>
-      </c:barChart>
-      <c:catAx>
-        <c:axId val="2094734554"/>
-        <c:scaling>
-          <c:orientation val="maxMin"/>
-        </c:scaling>
-        <c:delete val="0"/>
-        <c:axPos val="l"/>
-        <c:numFmt formatCode="General" sourceLinked="1"/>
-        <c:majorTickMark val="out"/>
-        <c:minorTickMark val="none"/>
-        <c:tickLblPos val="low"/>
-        <c:spPr>
-          <a:ln w="12700" cap="flat">
-            <a:solidFill>
-              <a:srgbClr val="888888"/>
-            </a:solidFill>
-            <a:prstDash val="solid"/>
-            <a:round/>
-          </a:ln>
-        </c:spPr>
-        <c:txPr>
-          <a:bodyPr/>
-          <a:lstStyle/>
-          <a:p>
-            <a:pPr>
-              <a:defRPr sz="1000" b="0" i="0" u="none" strike="noStrike">
-                <a:solidFill>
-                  <a:srgbClr val="404040"/>
-                </a:solidFill>
-                <a:latin typeface="Aptos"/>
-              </a:defRPr>
-            </a:pPr>
-            <a:endParaRPr lang="en-US"/>
-          </a:p>
-        </c:txPr>
-        <c:crossAx val="2094734552"/>
-        <c:crosses val="autoZero"/>
-        <c:auto val="1"/>
-        <c:lblAlgn val="ctr"/>
-        <c:noMultiLvlLbl val="1"/>
-      </c:catAx>
-      <c:valAx>
-        <c:axId val="2094734552"/>
-        <c:scaling>
-          <c:orientation val="minMax"/>
-          <c:max val="15"/>
-          <c:min val="-75"/>
-        </c:scaling>
-        <c:delete val="1"/>
-        <c:axPos val="b"/>
-        <c:numFmt formatCode="General" sourceLinked="0"/>
-        <c:majorTickMark val="out"/>
-        <c:minorTickMark val="none"/>
-        <c:tickLblPos val="low"/>
-        <c:spPr>
-          <a:ln w="12700" cap="flat">
-            <a:solidFill>
-              <a:srgbClr val="888888"/>
-            </a:solidFill>
-            <a:prstDash val="solid"/>
-            <a:round/>
-          </a:ln>
-        </c:spPr>
-        <c:txPr>
-          <a:bodyPr/>
-          <a:lstStyle/>
-          <a:p>
-            <a:pPr>
-              <a:defRPr sz="1200" b="0" i="0" u="none" strike="noStrike">
-                <a:solidFill>
-                  <a:srgbClr val="000000"/>
-                </a:solidFill>
-                <a:latin typeface="Arial"/>
-              </a:defRPr>
-            </a:pPr>
-            <a:endParaRPr lang="en-US"/>
-          </a:p>
-        </c:txPr>
-        <c:crossAx val="2094734554"/>
-        <c:crosses val="autoZero"/>
-        <c:crossBetween val="between"/>
-      </c:valAx>
-      <c:spPr>
-        <a:noFill/>
-        <a:ln>
-          <a:noFill/>
-        </a:ln>
-        <a:effectLst/>
-      </c:spPr>
-    </c:plotArea>
-    <c:plotVisOnly val="1"/>
-    <c:dispBlanksAs val="span"/>
-  </c:chart>
-  <c:spPr>
-    <a:noFill/>
-    <a:ln>
-      <a:noFill/>
-    </a:ln>
-    <a:effectLst/>
-  </c:spPr>
-  <c:externalData r:id="rId1">
-    <c:autoUpdate val="0"/>
-  </c:externalData>
-</c:chartSpace>
-</file>
-
-<file path=ppt/charts/chart6.xml><?xml version="1.0" encoding="utf-8"?>
 <c:chartSpace xmlns:c="http://schemas.openxmlformats.org/drawingml/2006/chart" xmlns:a="http://schemas.openxmlformats.org/drawingml/2006/main" xmlns:r="http://schemas.openxmlformats.org/officeDocument/2006/relationships">
   <c:date1904 val="0"/>
   <c:roundedCorners val="1"/>
@@ -3525,7 +3180,7 @@
               <a:rPr lang="en-US" dirty="0"/>
               <a:t>La baisse des émissions du commerce de détail français (−56 %) est la plus forte de l'UE-27. Elle reflète en partie la décarbonation de l'électricité : en 2024, 95 % de l'électricité française provenait de sources renouvelables et nucléaires (ministères de l'Aménagement du territoire et de la Transition écologique, 2026), le remplacement des fluides frigorigènes imposé par la réglementation européenne et le durcissement des cadres depuis le Plan Climat de 2017.
 L'enjeu suivant est le bâti : le décret tertiaire (décret n° 2019-771) impose des réductions de consommation aux bâtiments de plus de 1 000 m², ce qui concerne directement les grandes surfaces de périphérie (voir slide 7).
-Sources : OCDE, Air Emissions Accounts, https://www.oecd.org/en/data/datasets/air-emissions-accounts.html ; Légifrance, décret n° 2019-771 ; Bpifrance, Prêt Vert.</a:t>
+Sources : OCDE, Air Emissions Accounts, https://www.oecd.org/en/data/datasets/air-emissions-accounts.html ; Légifrance, décret n° 2019-771 ; Bpifrance, Prêt Vert ; de l'Estoile, E. et Salin, M. (2024), « Quantifier l'utilisation du foncier bâti par les secteurs économiques français pour évaluer leur vulnérabilité au Zéro Artificialisation Nette », Banque de France, document de travail n° 941, https://www.banque-france.fr/fr/publications-et-statistiques/publications/quantifier-lutilisation-du-foncier-bati-par-les-secteurs-economiques-francais-pour-evaluer-leur</a:t>
             </a:r>
             <a:endParaRPr lang="en-US" dirty="0"/>
           </a:p>
@@ -3703,14 +3358,16 @@
           <a:p>
             <a:r>
               <a:rPr lang="en-US" dirty="0"/>
-              <a:t>La fermeture des frontières au printemps 2020 est une expérience naturelle : les ventes de tabac ont augmenté de 21,9 % dans les départements frontaliers contre 2,4 % dans le reste de la France (Douchet, OFDT, 2021). La hausse atteint 44,6 % le long des frontières allemande et luxembourgeoise et 44,5 % le long des frontières espagnole et andorrane, mais seulement 2,6 % à la frontière suisse, où les prix sont proches des prix français (Assemblée nationale, 2021). L'Insee en déduit que les approvisionnements à l'étranger représentent au moins 9,5 % des ventes de tabac en France. KPMG estime à 11,9 % la part des cigarettes consommées en France achetées légalement à l'étranger ; l'étude est financée par un fabricant, mais ce chiffre est cohérent avec celui de l'Insee.
-Pour le carburant, les écarts de prix sont connus mais les flux ne sont pas mesurables avec les données publiques (ventes annuelles par département).
+              <a:t>Source principale : Insee Première n° 2075 (octobre 2025), fondé sur les paiements par carte anonymisés de 370 000 à 380 000 ménages clients du Crédit Mutuel Alliance Fédérale. Ce sont des données observées, pas des estimations de modèle.
+En 2024, plus d'un ménage sur deux des départements frontaliers a fait au moins un achat en magasin dans un pays voisin (huit sur dix dans les Pyrénées-Orientales). Les achats à l'étranger représentent 13,9 % des dépenses par carte en magasin en Moselle et 12 % dans les Pyrénées-Orientales ; la moyenne des 21 départements frontaliers est d'environ 7 %, contre moins de 3 % dans la plupart des autres départements. L'Allemagne, la Belgique et l'Espagne reçoivent chacune environ un cinquième des dépenses, la Suisse 16 % et le Luxembourg 15 %.
+Le panier acheté à l'étranger est très différent : carburant et tabac pèsent 31 % des dépenses à l'étranger contre 10 % en France, et 59 % au Luxembourg. Les flux réagissent vite aux taxes : la taxe carbone allemande de 2021 a divisé par deux la part du carburant acheté en Allemagne (Insee Analyses n° 97), et en 2024 les dépenses dans les bureaux de tabac italiens ont augmenté de 26 % (Insee Première n° 2075).
+Limites : une seule banque, clientèle un peu plus aisée que la moyenne, pas de montants en euros, pas de mesure des achats des étrangers en France. Tourisme compris, la France reste bénéficiaire nette au niveau national : les non-résidents y dépensent l'équivalent de 4,4 % de la consommation des ménages, les résidents 3,5 % à l'étranger (Eurostat, 2023).
 Références :
-- Assemblée nationale (2021), Rapport d'information n° 4498 sur la consommation de tabac pendant le confinement.
-- Douchet, M.-A. (2021), Tabagisme et arrêt du tabac en 2020, OFDT.
-- Hillion, M. et Monchâtre, V. (2024), « Les approvisionnements à l'étranger représentent au moins 9,5 % des ventes de tabac en France », Insee Analyses n° 94, https://www.insee.fr/fr/statistiques/7764897
-- KPMG (2025), Illicit cigarette consumption in Europe, results for 2024.
-- Commission européenne, Weekly Oil Bulletin ; AIE (2020), Luxembourg 2020 Energy Policy Review.
+- Ast, D. et Bichler, G. (2025), « En 2024, les achats de l'autre côté de la frontière représentent jusqu'à 14 % des dépenses physiques des résidents frontaliers », Insee Première n° 2075, https://www.insee.fr/fr/statistiques/8647092
+- Insee (2024), « Les résidents frontaliers ajustent fortement leurs achats de carburant en Allemagne à l'écart de prix avec la France », Insee Analyses n° 97, https://www.insee.fr/fr/statistiques/8236361
+- OFDT (2024), Approvisionnement en tabac 2022, https://www.ofdt.fr/sites/ofdt/files/2024-05/approvisionnement_tabac_2022.pdf
+- Hillion, M. et Monchâtre, V. (2024), Insee Analyses n° 94, https://www.insee.fr/fr/statistiques/7764897
+- Insee, recensements de la population 2012 et 2023 (actifs travaillant à l'étranger).
 - Eurostat (2025), nama_10_fcs.</a:t>
             </a:r>
             <a:endParaRPr lang="en-US" dirty="0"/>
@@ -3799,10 +3456,19 @@
           <a:p>
             <a:r>
               <a:rPr lang="en-US" dirty="0"/>
-              <a:t>Le tissu commercial frontalier n'est pas en déficit général : la densité de commerces est proche de la moyenne nationale, les super et hypermarchés y sont même un peu plus fréquents, et l'emploi salarié du commerce y a progressé comme au niveau national entre 2012 et 2024 (+9,5 % contre +9,6 %). La pression est sélective : les buralistes sont 25 % moins nombreux par habitant (64 % de moins le long de la frontière luxembourgeoise) et les stations-service 17 % moins nombreuses (57 % de moins face au Luxembourg). Ce sont des traces structurelles des achats à l'étranger.
-Côté politiques, les instruments spécifiques aux frontières concernent surtout le tabac (protocole buralistes, règles douanières). Les grands programmes nationaux de revitalisation ne prennent pas en compte l'exposition frontalière, et il n'existe pas de mesure officielle des achats transfrontaliers.
-Ces chiffres sont des calculs descriptifs sur des données officielles (Insee BPE 2025, Urssaf, annuaire DGDDI des buralistes 2018), pas des estimations de modèle.
-Références : Insee, Base permanente des équipements 2025 ; Urssaf, établissements et effectifs salariés par commune x APE ; DGDDI (2018), annuaire des buralistes ; DGDDI (2024), Achat et transport de tabac en Europe vers la France : les nouvelles règles en 2024 ; Commission européenne (2025), COM(2025) 580 ; ministère de l'Économie (2023), protocole d'accord avec la Confédération des buralistes 2023–2027 ; loi n° 2022-217 du 21 février 2022 (3DS).</a:t>
+              <a:t>Les frontières françaises ne se ressemblent pas. Trois profils ressortent des données Insee : des bassins de travail frontalier (Suisse, Luxembourg, Monaco), où les achats font partie des trajets quotidiens ; des achats de proximité réguliers (Allemagne, Belgique), guidés par les prix et l'assortiment ; des achats saisonniers et fiscaux (Espagne, Italie, Andorre), concentrés sur le tabac. Cette typologie est une lecture DGE des données de l'Insee Première n° 2075 et du recensement.
+Le tissu commercial frontalier n'est pas en déficit général (densité de commerces proche de la moyenne, emploi du commerce +9,5 % entre 2012 et 2024 comme au niveau national), mais il est aminci sur les produits taxés : buralistes et stations-service. Les créations d'entreprises du commerce, des transports et de l'hébergement sont 25 à 30 % moins nombreuses par commune frontalière. Thionville montre qu'une politique locale active peut inverser la tendance ; à l'inverse, la vacance reste élevée à Maubeuge (15,9 %), Cambrai (14,9 %) et Valenciennes (12,7 %).
+La coopération transfrontalière est dense (plus de 40 structures, ANCT, MOT), mais le commerce n'y est presque jamais une compétence explicite. Deux nouveautés : l'étude ESPON CROSSSHOP, première étude européenne sur les achats transfrontaliers (résultats en 2027), et le règlement BRIDGEforEU, dont l'ANCT est le point de coordination national. Un volet commerce renforcé est prévu dans le renouvellement d'Action Cœur de Ville et de Petites villes de demain après 2026 (mission Papin sur le commerce de proximité).
+Références :
+- Ast, D. et Bichler, G. (2025), Insee Première n° 2075, https://www.insee.fr/fr/statistiques/8647092
+- Insee, Base permanente des équipements 2025 ; DGDDI (2018), annuaire des buralistes (calculs des auteurs).
+- Insee, SIDE / Sirene 2024 (créations d'entreprises), note interne DGE.
+- ANCT (2025), Bilan Interreg 2014–2020 en France, https://media.anct.gouv.fr/ressources/2025-12/bilan-interreg-2024-2020-en-france.pdf
+- Euro-Institut (2025), étude CROSSSHOP, https://www.euroinstitut.org/fr/actualites-1-1/artikel/etude-crossshop-sur-les-flux-de-commerce-transfrontalier
+- Règlement (UE) 2025/925 (BRIDGEforEU) ; MOT, https://www.espaces-transfrontaliers.org/niveaux/europe-bridgeforeu/
+- Commission européenne (2025), COM(2025) 580 ; ministère de l'Économie (2023), protocole buralistes 2023–2027.
+- Interreg France-Wallonie-Vlaanderen, projet COMMERCE!, https://www.bge-hautsdefrance.fr/interreg-commerce/ ; CCI Alsace Eurométropole, Business Twin, https://www.alsace-eurometropole.cci.fr/business-twin-jumelages-dentreprises
+- Eurodistrict SaarMoselle (2025), résolution contre l'extension du FOC de Zweibrücken, https://www.saarmoselle.org/fr/actualites/resolution-de-l-eurodistrict-saarmoselle-contre-l-extension-du-foc-zweibrucken_-n.html</a:t>
             </a:r>
             <a:endParaRPr lang="en-US" dirty="0"/>
           </a:p>
@@ -3898,7 +3564,8 @@
 - Cerema (2023), Les données de géolocalisation des 1 500 zones commerciales de périphérie en open data, https://www.cerema.fr/fr/actualites/donnees-geolocalisation-1500-zones-commerciales-peripherie
 - Gouvernement (2023), Un nouvel horizon pour les zones commerciales, dossier de presse, septembre 2023, https://www.info.gouv.fr/upload/media/content/0001/07/2dc90efc2c1a0e97572bf027240fac63e4dc9d75.pdf
 - Bloch, K. et Pichavant, A.-S. (2026), « Entre 2016 et 2022, l'emploi salarié des points de vente progresse davantage en dehors des centres-villes », Insee Première n° 2091, https://www.insee.fr/fr/statistiques/8730497
-- Codata (2026), Digest 2026 ; relayé par L'Échommerces, https://lechommerces.fr/la-vacance-commerciale-progresse-de-nouveau-en-france/</a:t>
+- Codata (2026), Digest 2026 ; relayé par L'Échommerces, https://lechommerces.fr/la-vacance-commerciale-progresse-de-nouveau-en-france/
+- Conseil national du commerce (2026), La vacance commerciale en centre-ville, juin 2026, p. 71 (sondage Ifop pour l'ANCT et la Banque des Territoires), https://www.entreprises.gouv.fr/files/files/Entites/CNC/cnc_rapport_gt_vacance_commerciale.pdf</a:t>
             </a:r>
             <a:endParaRPr lang="en-US" dirty="0"/>
           </a:p>
@@ -3988,7 +3655,7 @@
               <a:rPr lang="en-US" dirty="0"/>
               <a:t>Cinquante ans de droit de l'urbanisme commercial sont passés d'une logique de protection des petits commerçants (lois Royer et Raffarin) à une logique de protection des sols (objectif ZAN, loi Climat et résilience de 2021). Les autorisations en CDAC ont chuté de 67 % entre 2019 et 2024 (Procos). L'extension n'est plus la voie principale ; la transformation de l'existant devient l'enjeu, avec en plus l'obligation de rénovation énergétique du décret tertiaire pour les grandes surfaces.
 Le plan de transformation des zones commerciales, lancé le 11 septembre 2023, soutient 90 projets pour 31,4 M€. C'est significatif pour chaque projet, mais modeste au regard des 1 500 zones. Montigny-lès-Cormeilles illustre ce qu'une transformation complète demande : du temps (démarche engagée en 2010), du portage foncier et un projet urbain.
-Point de comparaison européenne (à mentionner à l'oral) : parmi les pays ayant fixé des objectifs de réduction de l'artificialisation (Allemagne, Flandre, Wallonie, Luxembourg, Autriche), la France est la seule à l'avoir rendu juridiquement contraignant (Sarles-Frachon, mémoire EMSFI, 2022).
+Point de comparaison européenne (à mentionner à l'oral) : l'Allemagne, la Flandre, la Wallonie, le Luxembourg et l'Autriche ont fixé des objectifs quantitatifs de réduction de l'artificialisation, mais non contraignants ; la France est la seule à avoir inscrit le sien dans une loi contraignante (loi Climat et résilience) (Town Planning Review, 2024, https://doi.org/10.3828/tpr.2024.44). La loi du 20 juillet 2023 a ensuite assoupli la gouvernance du ZAN (garantie rurale d'un hectare).
 Références :
 - LSA (2025), « La fédération Procos pointe un reflux historique des autorisations de surface commerciales », https://www.lsa-conso.fr/la-federation-procos-pointe-un-reflux-historique-des-autorisations-de-surface-commerciales,137327
 - Ministère de l'Économie (2024), Plan de transformation des zones commerciales, https://presse.economie.gouv.fr/plan-de-transformation-des-zones-commerciales/ ; DGE (2024), Annonce des 74 lauréats, https://www.entreprises.gouv.fr/la-direction-generale-des-entreprises/actualites/annonce-74-laureats-plan-transformation-zones-commerciales
@@ -5566,7 +5233,7 @@
               <a:buChar char="•"/>
             </a:pPr>
             <a:r>
-              <a:rPr lang="en-US" sz="1250" b="1" dirty="0">
+              <a:rPr lang="en-US" sz="1150" b="1" dirty="0">
                 <a:solidFill>
                   <a:srgbClr val="003087"/>
                 </a:solidFill>
@@ -5583,7 +5250,7 @@
               <a:buNone/>
             </a:pPr>
             <a:r>
-              <a:rPr lang="en-US" sz="1250" dirty="0">
+              <a:rPr lang="en-US" sz="1150" dirty="0">
                 <a:solidFill>
                   <a:srgbClr val="404040"/>
                 </a:solidFill>
@@ -5593,7 +5260,7 @@
               </a:rPr>
               <a:t>les bâtiments tertiaires de plus de 1 000 m², dont les grandes surfaces, doivent réduire leur consommation d'énergie de 40 % en 2030, 50 % en 2040 et 60 % en 2050.</a:t>
             </a:r>
-            <a:endParaRPr lang="en-US" sz="1250" dirty="0"/>
+            <a:endParaRPr lang="en-US" sz="1150" dirty="0"/>
           </a:p>
           <a:p>
             <a:pPr marL="177800" indent="-177800">
@@ -5604,7 +5271,7 @@
               <a:buChar char="•"/>
             </a:pPr>
             <a:r>
-              <a:rPr lang="en-US" sz="1250" b="1" dirty="0">
+              <a:rPr lang="en-US" sz="1150" b="1" dirty="0">
                 <a:solidFill>
                   <a:srgbClr val="003087"/>
                 </a:solidFill>
@@ -5621,7 +5288,7 @@
               <a:buNone/>
             </a:pPr>
             <a:r>
-              <a:rPr lang="en-US" sz="1250" dirty="0">
+              <a:rPr lang="en-US" sz="1150" dirty="0">
                 <a:solidFill>
                   <a:srgbClr val="404040"/>
                 </a:solidFill>
@@ -5631,7 +5298,7 @@
               </a:rPr>
               <a:t>5 000 à 50 000 € sur 2 à 10 ans, adossé à un prêt bancaire équivalent.</a:t>
             </a:r>
-            <a:endParaRPr lang="en-US" sz="1250" dirty="0"/>
+            <a:endParaRPr lang="en-US" sz="1150" dirty="0"/>
           </a:p>
           <a:p>
             <a:pPr marL="177800" indent="-177800">
@@ -5642,7 +5309,7 @@
               <a:buChar char="•"/>
             </a:pPr>
             <a:r>
-              <a:rPr lang="en-US" sz="1250" b="1" dirty="0">
+              <a:rPr lang="en-US" sz="1150" b="1" dirty="0">
                 <a:solidFill>
                   <a:srgbClr val="003087"/>
                 </a:solidFill>
@@ -5650,7 +5317,7 @@
                 <a:ea typeface="Aptos" pitchFamily="34" charset="-122"/>
                 <a:cs typeface="Aptos" pitchFamily="34" charset="-120"/>
               </a:rPr>
-              <a:t>Un écosystème orienté vert : </a:t>
+              <a:t>Foncier : </a:t>
             </a:r>
             <a:pPr indent="0" marL="0">
               <a:spcAft>
@@ -5659,7 +5326,7 @@
               <a:buNone/>
             </a:pPr>
             <a:r>
-              <a:rPr lang="en-US" sz="1250" dirty="0">
+              <a:rPr lang="en-US" sz="1150" dirty="0">
                 <a:solidFill>
                   <a:srgbClr val="404040"/>
                 </a:solidFill>
@@ -5667,9 +5334,47 @@
                 <a:ea typeface="Aptos" pitchFamily="34" charset="-122"/>
                 <a:cs typeface="Aptos" pitchFamily="34" charset="-120"/>
               </a:rPr>
+              <a:t>le commerce a été le premier contributeur à l'artificialisation par le bâti économique entre 2008 et 2021, même si sa part diminue.</a:t>
+            </a:r>
+            <a:endParaRPr lang="en-US" sz="1150" dirty="0"/>
+          </a:p>
+          <a:p>
+            <a:pPr marL="177800" indent="-177800">
+              <a:spcAft>
+                <a:spcPts val="500"/>
+              </a:spcAft>
+              <a:buSzPct val="100000"/>
+              <a:buChar char="•"/>
+            </a:pPr>
+            <a:r>
+              <a:rPr lang="en-US" sz="1150" b="1" dirty="0">
+                <a:solidFill>
+                  <a:srgbClr val="003087"/>
+                </a:solidFill>
+                <a:latin typeface="Aptos" pitchFamily="34" charset="0"/>
+                <a:ea typeface="Aptos" pitchFamily="34" charset="-122"/>
+                <a:cs typeface="Aptos" pitchFamily="34" charset="-120"/>
+              </a:rPr>
+              <a:t>Un écosystème orienté vert : </a:t>
+            </a:r>
+            <a:pPr indent="0" marL="0">
+              <a:spcAft>
+                <a:spcPts val="500"/>
+              </a:spcAft>
+              <a:buNone/>
+            </a:pPr>
+            <a:r>
+              <a:rPr lang="en-US" sz="1150" dirty="0">
+                <a:solidFill>
+                  <a:srgbClr val="404040"/>
+                </a:solidFill>
+                <a:latin typeface="Aptos" pitchFamily="34" charset="0"/>
+                <a:ea typeface="Aptos" pitchFamily="34" charset="-122"/>
+                <a:cs typeface="Aptos" pitchFamily="34" charset="-120"/>
+              </a:rPr>
               <a:t>22 mesures uniquement « vertes » recensées, contre 5 uniquement numériques et 4 mixtes ; la plupart prennent la forme d'expertise plutôt que de financement.</a:t>
             </a:r>
-            <a:endParaRPr lang="en-US" sz="1250" dirty="0"/>
+            <a:endParaRPr lang="en-US" sz="1150" dirty="0"/>
           </a:p>
         </p:txBody>
       </p:sp>
@@ -5706,7 +5411,7 @@
                 <a:ea typeface="Aptos" pitchFamily="34" charset="-122"/>
                 <a:cs typeface="Aptos" pitchFamily="34" charset="-120"/>
               </a:rPr>
-              <a:t>Sources : OCDE (2026), Air Emissions Accounts (GES hors CO₂ de la biomasse, principe de résidence ; UE-27 estimée) ; décret n° 2019-771 du 23 juillet 2019 ; Bpifrance, Prêt Vert ; OCDE, inventaire des politiques (réunion DGE, 2026).</a:t>
+              <a:t>Sources : OCDE (2026), Air Emissions Accounts (GES hors CO₂ de la biomasse, principe de résidence ; UE-27 estimée) ; décret n° 2019-771 du 23 juillet 2019 ; Bpifrance, Prêt Vert ; de l'Estoile et Salin (2024), Banque de France, document de travail n° 941 ; OCDE, inventaire des politiques (réunion DGE, 2026).</a:t>
             </a:r>
             <a:endParaRPr lang="en-US" sz="900" dirty="0"/>
           </a:p>
@@ -6415,7 +6120,7 @@
                 <a:ea typeface="Aptos" pitchFamily="34" charset="-122"/>
                 <a:cs typeface="Aptos" pitchFamily="34" charset="-120"/>
               </a:rPr>
-              <a:t>Zones frontalières : la fermeture des frontières de 2020 a révélé l'ampleur des achats de tabac à l'étranger</a:t>
+              <a:t>Zones frontalières : les achats à l'étranger pèsent jusqu'à 14 % des dépenses en magasin des ménages frontaliers</a:t>
             </a:r>
             <a:endParaRPr lang="en-US" sz="2200" dirty="0"/>
           </a:p>
@@ -6518,7 +6223,7 @@
                 <a:ea typeface="Aptos" pitchFamily="34" charset="-122"/>
                 <a:cs typeface="Aptos" pitchFamily="34" charset="-120"/>
               </a:rPr>
-              <a:t>Hausse des ventes de tabac pendant la fermeture des frontières, printemps 2020 (% sur un an)</a:t>
+              <a:t>Part des dépenses par carte en magasin réalisée dans un pays voisin, 2024 (%, 12 premiers départements)</a:t>
             </a:r>
             <a:endParaRPr lang="en-US" sz="1200" dirty="0"/>
           </a:p>
@@ -6590,7 +6295,7 @@
               <a:buNone/>
             </a:pPr>
             <a:r>
-              <a:rPr lang="en-US" sz="2800" b="1" dirty="0">
+              <a:rPr lang="en-US" sz="2400" b="1" dirty="0">
                 <a:solidFill>
                   <a:srgbClr val="003087"/>
                 </a:solidFill>
@@ -6598,9 +6303,9 @@
                 <a:ea typeface="Aptos" pitchFamily="34" charset="-122"/>
                 <a:cs typeface="Aptos" pitchFamily="34" charset="-120"/>
               </a:rPr>
-              <a:t>≥ 9,5 %</a:t>
-            </a:r>
-            <a:endParaRPr lang="en-US" sz="2800" dirty="0"/>
+              <a:t>&gt; 1 sur 2</a:t>
+            </a:r>
+            <a:endParaRPr lang="en-US" sz="2400" dirty="0"/>
           </a:p>
         </p:txBody>
       </p:sp>
@@ -6637,7 +6342,7 @@
                 <a:ea typeface="Aptos" pitchFamily="34" charset="-122"/>
                 <a:cs typeface="Aptos" pitchFamily="34" charset="-120"/>
               </a:rPr>
-              <a:t>des ventes de tabac en France correspondent à des achats à l'étranger (Insee)</a:t>
+              <a:t>des ménages des départements frontaliers ont acheté en magasin à l'étranger en 2024</a:t>
             </a:r>
             <a:endParaRPr lang="en-US" sz="1100" dirty="0"/>
           </a:p>
@@ -6701,7 +6406,7 @@
                 <a:ea typeface="Aptos" pitchFamily="34" charset="-122"/>
                 <a:cs typeface="Aptos" pitchFamily="34" charset="-120"/>
               </a:rPr>
-              <a:t>11,9 %</a:t>
+              <a:t>31 %</a:t>
             </a:r>
             <a:endParaRPr lang="en-US" sz="2800" dirty="0"/>
           </a:p>
@@ -6740,7 +6445,7 @@
                 <a:ea typeface="Aptos" pitchFamily="34" charset="-122"/>
                 <a:cs typeface="Aptos" pitchFamily="34" charset="-120"/>
               </a:rPr>
-              <a:t>des cigarettes consommées en France achetées légalement à l'étranger en 2024 (KPMG)</a:t>
+              <a:t>de leurs dépenses à l'étranger vont au carburant et au tabac, contre 10 % en France (59 % au Luxembourg)</a:t>
             </a:r>
             <a:endParaRPr lang="en-US" sz="1100" dirty="0"/>
           </a:p>
@@ -6775,7 +6480,7 @@
               <a:buChar char="•"/>
             </a:pPr>
             <a:r>
-              <a:rPr lang="en-US" sz="1200" b="1" dirty="0">
+              <a:rPr lang="en-US" sz="1100" b="1" dirty="0">
                 <a:solidFill>
                   <a:srgbClr val="003087"/>
                 </a:solidFill>
@@ -6783,7 +6488,7 @@
                 <a:ea typeface="Aptos" pitchFamily="34" charset="-122"/>
                 <a:cs typeface="Aptos" pitchFamily="34" charset="-120"/>
               </a:rPr>
-              <a:t>Carburant : </a:t>
+              <a:t>Frontaliers : </a:t>
             </a:r>
             <a:pPr indent="0" marL="0">
               <a:spcAft>
@@ -6792,7 +6497,7 @@
               <a:buNone/>
             </a:pPr>
             <a:r>
-              <a:rPr lang="en-US" sz="1200" dirty="0">
+              <a:rPr lang="en-US" sz="1100" dirty="0">
                 <a:solidFill>
                   <a:srgbClr val="404040"/>
                 </a:solidFill>
@@ -6800,9 +6505,9 @@
                 <a:ea typeface="Aptos" pitchFamily="34" charset="-122"/>
                 <a:cs typeface="Aptos" pitchFamily="34" charset="-120"/>
               </a:rPr>
-              <a:t>pendant la fermeture, le sans-plomb coûtait 1,28 €/l en France contre 0,97 € au Luxembourg ; les non-résidents y achètent environ deux tiers du carburant routier.</a:t>
-            </a:r>
-            <a:endParaRPr lang="en-US" sz="1200" dirty="0"/>
+              <a:t>505 700 résidents travaillent à l'étranger en 2023 (+41 % depuis 2012), dont 71,5 % en Suisse et au Luxembourg ; près de ces deux pays, moins de 15 % des ménages, très réguliers, font environ la moitié des dépenses.</a:t>
+            </a:r>
+            <a:endParaRPr lang="en-US" sz="1100" dirty="0"/>
           </a:p>
           <a:p>
             <a:pPr marL="177800" indent="-177800">
@@ -6813,7 +6518,7 @@
               <a:buChar char="•"/>
             </a:pPr>
             <a:r>
-              <a:rPr lang="en-US" sz="1200" b="1" dirty="0">
+              <a:rPr lang="en-US" sz="1100" b="1" dirty="0">
                 <a:solidFill>
                   <a:srgbClr val="003087"/>
                 </a:solidFill>
@@ -6821,7 +6526,7 @@
                 <a:ea typeface="Aptos" pitchFamily="34" charset="-122"/>
                 <a:cs typeface="Aptos" pitchFamily="34" charset="-120"/>
               </a:rPr>
-              <a:t>Sans données mensuelles : </a:t>
+              <a:t>Sensibilité aux taxes : </a:t>
             </a:r>
             <a:pPr indent="0" marL="0">
               <a:spcAft>
@@ -6830,7 +6535,7 @@
               <a:buNone/>
             </a:pPr>
             <a:r>
-              <a:rPr lang="en-US" sz="1200" dirty="0">
+              <a:rPr lang="en-US" sz="1100" dirty="0">
                 <a:solidFill>
                   <a:srgbClr val="404040"/>
                 </a:solidFill>
@@ -6838,9 +6543,9 @@
                 <a:ea typeface="Aptos" pitchFamily="34" charset="-122"/>
                 <a:cs typeface="Aptos" pitchFamily="34" charset="-120"/>
               </a:rPr>
-              <a:t>les ventes de carburant ne sont publiées qu'à l'échelle annuelle par département, ce qui empêche de mesurer les flux.</a:t>
-            </a:r>
-            <a:endParaRPr lang="en-US" sz="1200" dirty="0"/>
+              <a:t>après la taxe carbone allemande de janvier 2021, la part du carburant acheté en Allemagne par les ménages de Moselle et d'Alsace passe de plus de 15 % à environ 8 %.</a:t>
+            </a:r>
+            <a:endParaRPr lang="en-US" sz="1100" dirty="0"/>
           </a:p>
           <a:p>
             <a:pPr marL="177800" indent="-177800">
@@ -6851,7 +6556,7 @@
               <a:buChar char="•"/>
             </a:pPr>
             <a:r>
-              <a:rPr lang="en-US" sz="1200" b="1" dirty="0">
+              <a:rPr lang="en-US" sz="1100" b="1" dirty="0">
                 <a:solidFill>
                   <a:srgbClr val="003087"/>
                 </a:solidFill>
@@ -6859,7 +6564,7 @@
                 <a:ea typeface="Aptos" pitchFamily="34" charset="-122"/>
                 <a:cs typeface="Aptos" pitchFamily="34" charset="-120"/>
               </a:rPr>
-              <a:t>Vue d'ensemble : </a:t>
+              <a:t>Tabac : </a:t>
             </a:r>
             <a:pPr indent="0" marL="0">
               <a:spcAft>
@@ -6868,7 +6573,7 @@
               <a:buNone/>
             </a:pPr>
             <a:r>
-              <a:rPr lang="en-US" sz="1200" dirty="0">
+              <a:rPr lang="en-US" sz="1100" dirty="0">
                 <a:solidFill>
                   <a:srgbClr val="404040"/>
                 </a:solidFill>
@@ -6876,9 +6581,9 @@
                 <a:ea typeface="Aptos" pitchFamily="34" charset="-122"/>
                 <a:cs typeface="Aptos" pitchFamily="34" charset="-120"/>
               </a:rPr>
-              <a:t>tourisme compris, la France reste bénéficiaire : les non-résidents y dépensent l'équivalent de 4,4 % de la consommation des ménages, les résidents 3,5 % à l'étranger (2023).</a:t>
-            </a:r>
-            <a:endParaRPr lang="en-US" sz="1200" dirty="0"/>
+              <a:t>ventes des buralistes −33 % entre 2017 et 2022 dans les départements frontaliers, contre −25 % ailleurs (−46 % en Moselle) ; au moins 9,5 % des ventes nationales sont des achats à l'étranger (fermeture de 2020).</a:t>
+            </a:r>
+            <a:endParaRPr lang="en-US" sz="1100" dirty="0"/>
           </a:p>
         </p:txBody>
       </p:sp>
@@ -6915,7 +6620,7 @@
                 <a:ea typeface="Aptos" pitchFamily="34" charset="-122"/>
                 <a:cs typeface="Aptos" pitchFamily="34" charset="-120"/>
               </a:rPr>
-              <a:t>Note : façades, 16 mars–14 juin 2020 ; ensemble des départements frontaliers et reste de la France, 2e trimestre 2020.</a:t>
+              <a:t>Note : paiements par carte en magasin des clients du Crédit Mutuel Alliance Fédérale (hors espèces et internet) ; moyenne des 21 départements frontaliers ≈ 7 %, moins de 3 % dans la plupart des autres.</a:t>
             </a:r>
             <a:endParaRPr lang="en-US" sz="900" dirty="0"/>
           </a:p>
@@ -6932,7 +6637,7 @@
                 <a:ea typeface="Aptos" pitchFamily="34" charset="-122"/>
                 <a:cs typeface="Aptos" pitchFamily="34" charset="-120"/>
               </a:rPr>
-              <a:t>Sources : Assemblée nationale (2021), rapport d'information n° 4498 ; Douchet (2021), OFDT ; Hillion et Monchâtre (2024), Insee Analyses n° 94 ; KPMG (2025), étude commandée par PMI ; Commission européenne, Bulletin pétrolier ; AIE (2020) ; SDES ; Eurostat (2025), nama_10_fcs (P33, P34).</a:t>
+              <a:t>Sources : Ast et Bichler (2025), Insee Première n° 2075 ; Insee, recensements de la population ; Insee Analyses n° 97 (2024) ; OFDT (2024) ; Hillion et Monchâtre (2024), Insee Analyses n° 94.</a:t>
             </a:r>
             <a:endParaRPr lang="en-US" sz="900" dirty="0"/>
           </a:p>
@@ -7028,7 +6733,7 @@
                 <a:ea typeface="Aptos" pitchFamily="34" charset="-122"/>
                 <a:cs typeface="Aptos" pitchFamily="34" charset="-120"/>
               </a:rPr>
-              <a:t>Zones frontalières : un tissu commercial solide mais aminci là où les écarts de prix sont forts ; des politiques peu territorialisées</a:t>
+              <a:t>Zones frontalières : trois profils de frontière, un tissu aminci sur les produits taxés, des politiques qui ne visent pas le commerce</a:t>
             </a:r>
             <a:endParaRPr lang="en-US" sz="2200" dirty="0"/>
           </a:p>
@@ -7106,7 +6811,7 @@
         </p:nvSpPr>
         <p:spPr>
           <a:xfrm>
-            <a:off x="365760" y="1051560"/>
+            <a:off x="365760" y="1005840"/>
             <a:ext cx="5394960" cy="365760"/>
           </a:xfrm>
           <a:prstGeom prst="rect">
@@ -7131,64 +6836,9 @@
                 <a:ea typeface="Aptos" pitchFamily="34" charset="-122"/>
                 <a:cs typeface="Aptos" pitchFamily="34" charset="-120"/>
               </a:rPr>
-              <a:t>Densité d'équipements, zone frontalière (0–20 km) par rapport à la France métropolitaine (écart en %)</a:t>
+              <a:t>Trois profils de frontière (achats des ménages frontaliers, 2024)</a:t>
             </a:r>
             <a:endParaRPr lang="en-US" sz="1200" dirty="0"/>
-          </a:p>
-        </p:txBody>
-      </p:sp>
-      <p:graphicFrame>
-        <p:nvGraphicFramePr>
-          <p:cNvPr id="7" name="Chart 0" descr=""/>
-          <p:cNvGraphicFramePr/>
-          <p:nvPr/>
-        </p:nvGraphicFramePr>
-        <p:xfrm>
-          <a:off x="274320" y="1463040"/>
-          <a:ext cx="5394960" cy="3977640"/>
-        </p:xfrm>
-        <a:graphic xmlns:a="http://schemas.openxmlformats.org/drawingml/2006/main">
-          <a:graphicData uri="http://schemas.openxmlformats.org/drawingml/2006/chart">
-            <c:chart xmlns:c="http://schemas.openxmlformats.org/drawingml/2006/chart" r:id="rId1"/>
-          </a:graphicData>
-        </a:graphic>
-      </p:graphicFrame>
-      <p:sp>
-        <p:nvSpPr>
-          <p:cNvPr id="8" name="Text 5"/>
-          <p:cNvSpPr txBox="1"/>
-          <p:nvPr/>
-        </p:nvSpPr>
-        <p:spPr>
-          <a:xfrm>
-            <a:off x="365760" y="5440680"/>
-            <a:ext cx="5303520" cy="457200"/>
-          </a:xfrm>
-          <a:prstGeom prst="rect">
-            <a:avLst/>
-          </a:prstGeom>
-          <a:noFill/>
-          <a:ln/>
-        </p:spPr>
-        <p:txBody>
-          <a:bodyPr wrap="square" lIns="0" tIns="0" rIns="0" bIns="0" rtlCol="0" anchor="t"/>
-          <a:lstStyle/>
-          <a:p>
-            <a:pPr indent="0" marL="0">
-              <a:buNone/>
-            </a:pPr>
-            <a:r>
-              <a:rPr lang="en-US" sz="1100" b="1" dirty="0">
-                <a:solidFill>
-                  <a:srgbClr val="003087"/>
-                </a:solidFill>
-                <a:latin typeface="Aptos" pitchFamily="34" charset="0"/>
-                <a:ea typeface="Aptos" pitchFamily="34" charset="-122"/>
-                <a:cs typeface="Aptos" pitchFamily="34" charset="-120"/>
-              </a:rPr>
-              <a:t>Emploi salarié du commerce de détail, 2012–2024 : +9,5 % en zone frontalière, +9,6 % en France métropolitaine.</a:t>
-            </a:r>
-            <a:endParaRPr lang="en-US" sz="1100" dirty="0"/>
           </a:p>
         </p:txBody>
       </p:sp>
@@ -7207,19 +6857,18 @@
           </p:nvPr>
         </p:nvGraphicFramePr>
         <p:xfrm>
-          <a:off x="5943600" y="1097280"/>
-          <a:ext cx="5897880" cy="914400"/>
+          <a:off x="365760" y="1417320"/>
+          <a:ext cx="5394960" cy="914400"/>
         </p:xfrm>
         <a:graphic>
           <a:graphicData uri="http://schemas.openxmlformats.org/drawingml/2006/table">
             <a:tbl>
               <a:tblPr/>
               <a:tblGrid>
-                <a:gridCol w="868680"/>
                 <a:gridCol w="1920240"/>
-                <a:gridCol w="3108960"/>
+                <a:gridCol w="3474720"/>
               </a:tblGrid>
-              <a:tr h="566928">
+              <a:tr h="320040">
                 <a:tc>
                   <a:txBody>
                     <a:bodyPr/>
@@ -7229,7 +6878,7 @@
                         <a:buNone/>
                       </a:pPr>
                       <a:r>
-                        <a:rPr lang="en-US" sz="1000" b="1" dirty="0">
+                        <a:rPr lang="en-US" sz="950" b="1" dirty="0">
                           <a:solidFill>
                             <a:srgbClr val="FFFFFF"/>
                           </a:solidFill>
@@ -7237,9 +6886,9 @@
                           <a:ea typeface="Aptos" pitchFamily="34" charset="-122"/>
                           <a:cs typeface="Aptos" pitchFamily="34" charset="-120"/>
                         </a:rPr>
-                        <a:t>Niveau</a:t>
+                        <a:t>Profil</a:t>
                       </a:r>
-                      <a:endParaRPr lang="en-US" sz="1000" dirty="0">
+                      <a:endParaRPr lang="en-US" sz="950" dirty="0">
                         <a:latin typeface="Aptos" charset="0"/>
                         <a:ea typeface="Aptos" charset="0"/>
                         <a:cs typeface="Aptos" charset="0"/>
@@ -7297,7 +6946,7 @@
                         <a:buNone/>
                       </a:pPr>
                       <a:r>
-                        <a:rPr lang="en-US" sz="1000" b="1" dirty="0">
+                        <a:rPr lang="en-US" sz="950" b="1" dirty="0">
                           <a:solidFill>
                             <a:srgbClr val="FFFFFF"/>
                           </a:solidFill>
@@ -7305,9 +6954,757 @@
                           <a:ea typeface="Aptos" pitchFamily="34" charset="-122"/>
                           <a:cs typeface="Aptos" pitchFamily="34" charset="-120"/>
                         </a:rPr>
-                        <a:t>Instrument</a:t>
+                        <a:t>Ce que montrent les données</a:t>
                       </a:r>
-                      <a:endParaRPr lang="en-US" sz="1000" dirty="0">
+                      <a:endParaRPr lang="en-US" sz="950" dirty="0">
+                        <a:latin typeface="Aptos" charset="0"/>
+                        <a:ea typeface="Aptos" charset="0"/>
+                        <a:cs typeface="Aptos" charset="0"/>
+                      </a:endParaRPr>
+                    </a:p>
+                  </a:txBody>
+                  <a:tcPr marL="63500" marR="63500" marT="38100" marB="38100" anchor="ctr">
+                    <a:lnL w="6350" cap="flat" cmpd="sng" algn="ctr">
+                      <a:solidFill>
+                        <a:srgbClr val="D5DCE4"/>
+                      </a:solidFill>
+                      <a:prstDash val="solid"/>
+                      <a:round/>
+                      <a:headEnd type="none" w="med" len="med"/>
+                      <a:tailEnd type="none" w="med" len="med"/>
+                    </a:lnL>
+                    <a:lnR w="6350" cap="flat" cmpd="sng" algn="ctr">
+                      <a:solidFill>
+                        <a:srgbClr val="D5DCE4"/>
+                      </a:solidFill>
+                      <a:prstDash val="solid"/>
+                      <a:round/>
+                      <a:headEnd type="none" w="med" len="med"/>
+                      <a:tailEnd type="none" w="med" len="med"/>
+                    </a:lnR>
+                    <a:lnT w="6350" cap="flat" cmpd="sng" algn="ctr">
+                      <a:solidFill>
+                        <a:srgbClr val="D5DCE4"/>
+                      </a:solidFill>
+                      <a:prstDash val="solid"/>
+                      <a:round/>
+                      <a:headEnd type="none" w="med" len="med"/>
+                      <a:tailEnd type="none" w="med" len="med"/>
+                    </a:lnT>
+                    <a:lnB w="6350" cap="flat" cmpd="sng" algn="ctr">
+                      <a:solidFill>
+                        <a:srgbClr val="D5DCE4"/>
+                      </a:solidFill>
+                      <a:prstDash val="solid"/>
+                      <a:round/>
+                      <a:headEnd type="none" w="med" len="med"/>
+                      <a:tailEnd type="none" w="med" len="med"/>
+                    </a:lnB>
+                    <a:solidFill>
+                      <a:srgbClr val="0070C0"/>
+                    </a:solidFill>
+                  </a:tcPr>
+                </a:tc>
+              </a:tr>
+              <a:tr h="713232">
+                <a:tc>
+                  <a:txBody>
+                    <a:bodyPr/>
+                    <a:lstStyle/>
+                    <a:p>
+                      <a:pPr indent="0" marL="0">
+                        <a:buNone/>
+                      </a:pPr>
+                      <a:r>
+                        <a:rPr lang="en-US" sz="950" b="1" dirty="0">
+                          <a:solidFill>
+                            <a:srgbClr val="003087"/>
+                          </a:solidFill>
+                          <a:latin typeface="Aptos" pitchFamily="34" charset="0"/>
+                          <a:ea typeface="Aptos" pitchFamily="34" charset="-122"/>
+                          <a:cs typeface="Aptos" pitchFamily="34" charset="-120"/>
+                        </a:rPr>
+                        <a:t>Bassins de travail frontalier</a:t>
+                      </a:r>
+                      <a:endParaRPr lang="en-US" sz="950" dirty="0">
+                        <a:latin typeface="Aptos" charset="0"/>
+                        <a:ea typeface="Aptos" charset="0"/>
+                        <a:cs typeface="Aptos" charset="0"/>
+                      </a:endParaRPr>
+                    </a:p>
+                    <a:p>
+                      <a:pPr indent="0" marL="0">
+                        <a:buNone/>
+                      </a:pPr>
+                      <a:r>
+                        <a:rPr lang="en-US" sz="950" dirty="0">
+                          <a:solidFill>
+                            <a:srgbClr val="404040"/>
+                          </a:solidFill>
+                          <a:latin typeface="Aptos" pitchFamily="34" charset="0"/>
+                          <a:ea typeface="Aptos" pitchFamily="34" charset="-122"/>
+                          <a:cs typeface="Aptos" pitchFamily="34" charset="-120"/>
+                        </a:rPr>
+                        <a:t>Suisse, Luxembourg, Monaco</a:t>
+                      </a:r>
+                      <a:endParaRPr lang="en-US" sz="950" dirty="0">
+                        <a:latin typeface="Aptos" charset="0"/>
+                        <a:ea typeface="Aptos" charset="0"/>
+                        <a:cs typeface="Aptos" charset="0"/>
+                      </a:endParaRPr>
+                    </a:p>
+                  </a:txBody>
+                  <a:tcPr marL="63500" marR="63500" marT="38100" marB="38100" anchor="ctr">
+                    <a:lnL w="6350" cap="flat" cmpd="sng" algn="ctr">
+                      <a:solidFill>
+                        <a:srgbClr val="D5DCE4"/>
+                      </a:solidFill>
+                      <a:prstDash val="solid"/>
+                      <a:round/>
+                      <a:headEnd type="none" w="med" len="med"/>
+                      <a:tailEnd type="none" w="med" len="med"/>
+                    </a:lnL>
+                    <a:lnR w="6350" cap="flat" cmpd="sng" algn="ctr">
+                      <a:solidFill>
+                        <a:srgbClr val="D5DCE4"/>
+                      </a:solidFill>
+                      <a:prstDash val="solid"/>
+                      <a:round/>
+                      <a:headEnd type="none" w="med" len="med"/>
+                      <a:tailEnd type="none" w="med" len="med"/>
+                    </a:lnR>
+                    <a:lnT w="6350" cap="flat" cmpd="sng" algn="ctr">
+                      <a:solidFill>
+                        <a:srgbClr val="D5DCE4"/>
+                      </a:solidFill>
+                      <a:prstDash val="solid"/>
+                      <a:round/>
+                      <a:headEnd type="none" w="med" len="med"/>
+                      <a:tailEnd type="none" w="med" len="med"/>
+                    </a:lnT>
+                    <a:lnB w="6350" cap="flat" cmpd="sng" algn="ctr">
+                      <a:solidFill>
+                        <a:srgbClr val="D5DCE4"/>
+                      </a:solidFill>
+                      <a:prstDash val="solid"/>
+                      <a:round/>
+                      <a:headEnd type="none" w="med" len="med"/>
+                      <a:tailEnd type="none" w="med" len="med"/>
+                    </a:lnB>
+                  </a:tcPr>
+                </a:tc>
+                <a:tc>
+                  <a:txBody>
+                    <a:bodyPr/>
+                    <a:lstStyle/>
+                    <a:p>
+                      <a:pPr indent="0" marL="0">
+                        <a:buNone/>
+                      </a:pPr>
+                      <a:r>
+                        <a:rPr lang="en-US" sz="950" dirty="0">
+                          <a:solidFill>
+                            <a:srgbClr val="404040"/>
+                          </a:solidFill>
+                          <a:latin typeface="Aptos" pitchFamily="34" charset="0"/>
+                          <a:ea typeface="Aptos" pitchFamily="34" charset="-122"/>
+                          <a:cs typeface="Aptos" pitchFamily="34" charset="-120"/>
+                        </a:rPr>
+                        <a:t>380 000 frontaliers ; achats intégrés aux trajets quotidiens ; carburant et tabac : 59 % des dépenses au Luxembourg</a:t>
+                      </a:r>
+                      <a:endParaRPr lang="en-US" sz="950" dirty="0">
+                        <a:latin typeface="Aptos" charset="0"/>
+                        <a:ea typeface="Aptos" charset="0"/>
+                        <a:cs typeface="Aptos" charset="0"/>
+                      </a:endParaRPr>
+                    </a:p>
+                  </a:txBody>
+                  <a:tcPr marL="63500" marR="63500" marT="38100" marB="38100" anchor="ctr">
+                    <a:lnL w="6350" cap="flat" cmpd="sng" algn="ctr">
+                      <a:solidFill>
+                        <a:srgbClr val="D5DCE4"/>
+                      </a:solidFill>
+                      <a:prstDash val="solid"/>
+                      <a:round/>
+                      <a:headEnd type="none" w="med" len="med"/>
+                      <a:tailEnd type="none" w="med" len="med"/>
+                    </a:lnL>
+                    <a:lnR w="6350" cap="flat" cmpd="sng" algn="ctr">
+                      <a:solidFill>
+                        <a:srgbClr val="D5DCE4"/>
+                      </a:solidFill>
+                      <a:prstDash val="solid"/>
+                      <a:round/>
+                      <a:headEnd type="none" w="med" len="med"/>
+                      <a:tailEnd type="none" w="med" len="med"/>
+                    </a:lnR>
+                    <a:lnT w="6350" cap="flat" cmpd="sng" algn="ctr">
+                      <a:solidFill>
+                        <a:srgbClr val="D5DCE4"/>
+                      </a:solidFill>
+                      <a:prstDash val="solid"/>
+                      <a:round/>
+                      <a:headEnd type="none" w="med" len="med"/>
+                      <a:tailEnd type="none" w="med" len="med"/>
+                    </a:lnT>
+                    <a:lnB w="6350" cap="flat" cmpd="sng" algn="ctr">
+                      <a:solidFill>
+                        <a:srgbClr val="D5DCE4"/>
+                      </a:solidFill>
+                      <a:prstDash val="solid"/>
+                      <a:round/>
+                      <a:headEnd type="none" w="med" len="med"/>
+                      <a:tailEnd type="none" w="med" len="med"/>
+                    </a:lnB>
+                  </a:tcPr>
+                </a:tc>
+              </a:tr>
+              <a:tr h="713232">
+                <a:tc>
+                  <a:txBody>
+                    <a:bodyPr/>
+                    <a:lstStyle/>
+                    <a:p>
+                      <a:pPr indent="0" marL="0">
+                        <a:buNone/>
+                      </a:pPr>
+                      <a:r>
+                        <a:rPr lang="en-US" sz="950" b="1" dirty="0">
+                          <a:solidFill>
+                            <a:srgbClr val="003087"/>
+                          </a:solidFill>
+                          <a:latin typeface="Aptos" pitchFamily="34" charset="0"/>
+                          <a:ea typeface="Aptos" pitchFamily="34" charset="-122"/>
+                          <a:cs typeface="Aptos" pitchFamily="34" charset="-120"/>
+                        </a:rPr>
+                        <a:t>Achats de proximité réguliers</a:t>
+                      </a:r>
+                      <a:endParaRPr lang="en-US" sz="950" dirty="0">
+                        <a:latin typeface="Aptos" charset="0"/>
+                        <a:ea typeface="Aptos" charset="0"/>
+                        <a:cs typeface="Aptos" charset="0"/>
+                      </a:endParaRPr>
+                    </a:p>
+                    <a:p>
+                      <a:pPr indent="0" marL="0">
+                        <a:buNone/>
+                      </a:pPr>
+                      <a:r>
+                        <a:rPr lang="en-US" sz="950" dirty="0">
+                          <a:solidFill>
+                            <a:srgbClr val="404040"/>
+                          </a:solidFill>
+                          <a:latin typeface="Aptos" pitchFamily="34" charset="0"/>
+                          <a:ea typeface="Aptos" pitchFamily="34" charset="-122"/>
+                          <a:cs typeface="Aptos" pitchFamily="34" charset="-120"/>
+                        </a:rPr>
+                        <a:t>Allemagne, Belgique</a:t>
+                      </a:r>
+                      <a:endParaRPr lang="en-US" sz="950" dirty="0">
+                        <a:latin typeface="Aptos" charset="0"/>
+                        <a:ea typeface="Aptos" charset="0"/>
+                        <a:cs typeface="Aptos" charset="0"/>
+                      </a:endParaRPr>
+                    </a:p>
+                  </a:txBody>
+                  <a:tcPr marL="63500" marR="63500" marT="38100" marB="38100" anchor="ctr">
+                    <a:lnL w="6350" cap="flat" cmpd="sng" algn="ctr">
+                      <a:solidFill>
+                        <a:srgbClr val="D5DCE4"/>
+                      </a:solidFill>
+                      <a:prstDash val="solid"/>
+                      <a:round/>
+                      <a:headEnd type="none" w="med" len="med"/>
+                      <a:tailEnd type="none" w="med" len="med"/>
+                    </a:lnL>
+                    <a:lnR w="6350" cap="flat" cmpd="sng" algn="ctr">
+                      <a:solidFill>
+                        <a:srgbClr val="D5DCE4"/>
+                      </a:solidFill>
+                      <a:prstDash val="solid"/>
+                      <a:round/>
+                      <a:headEnd type="none" w="med" len="med"/>
+                      <a:tailEnd type="none" w="med" len="med"/>
+                    </a:lnR>
+                    <a:lnT w="6350" cap="flat" cmpd="sng" algn="ctr">
+                      <a:solidFill>
+                        <a:srgbClr val="D5DCE4"/>
+                      </a:solidFill>
+                      <a:prstDash val="solid"/>
+                      <a:round/>
+                      <a:headEnd type="none" w="med" len="med"/>
+                      <a:tailEnd type="none" w="med" len="med"/>
+                    </a:lnT>
+                    <a:lnB w="6350" cap="flat" cmpd="sng" algn="ctr">
+                      <a:solidFill>
+                        <a:srgbClr val="D5DCE4"/>
+                      </a:solidFill>
+                      <a:prstDash val="solid"/>
+                      <a:round/>
+                      <a:headEnd type="none" w="med" len="med"/>
+                      <a:tailEnd type="none" w="med" len="med"/>
+                    </a:lnB>
+                  </a:tcPr>
+                </a:tc>
+                <a:tc>
+                  <a:txBody>
+                    <a:bodyPr/>
+                    <a:lstStyle/>
+                    <a:p>
+                      <a:pPr indent="0" marL="0">
+                        <a:buNone/>
+                      </a:pPr>
+                      <a:r>
+                        <a:rPr lang="en-US" sz="950" dirty="0">
+                          <a:solidFill>
+                            <a:srgbClr val="404040"/>
+                          </a:solidFill>
+                          <a:latin typeface="Aptos" pitchFamily="34" charset="0"/>
+                          <a:ea typeface="Aptos" pitchFamily="34" charset="-122"/>
+                          <a:cs typeface="Aptos" pitchFamily="34" charset="-120"/>
+                        </a:rPr>
+                        <a:t>Agglomérations à cheval sur la frontière ; prix et assortiment (droguerie, équipement) ; carburant et tabac : 27 à 36 %</a:t>
+                      </a:r>
+                      <a:endParaRPr lang="en-US" sz="950" dirty="0">
+                        <a:latin typeface="Aptos" charset="0"/>
+                        <a:ea typeface="Aptos" charset="0"/>
+                        <a:cs typeface="Aptos" charset="0"/>
+                      </a:endParaRPr>
+                    </a:p>
+                  </a:txBody>
+                  <a:tcPr marL="63500" marR="63500" marT="38100" marB="38100" anchor="ctr">
+                    <a:lnL w="6350" cap="flat" cmpd="sng" algn="ctr">
+                      <a:solidFill>
+                        <a:srgbClr val="D5DCE4"/>
+                      </a:solidFill>
+                      <a:prstDash val="solid"/>
+                      <a:round/>
+                      <a:headEnd type="none" w="med" len="med"/>
+                      <a:tailEnd type="none" w="med" len="med"/>
+                    </a:lnL>
+                    <a:lnR w="6350" cap="flat" cmpd="sng" algn="ctr">
+                      <a:solidFill>
+                        <a:srgbClr val="D5DCE4"/>
+                      </a:solidFill>
+                      <a:prstDash val="solid"/>
+                      <a:round/>
+                      <a:headEnd type="none" w="med" len="med"/>
+                      <a:tailEnd type="none" w="med" len="med"/>
+                    </a:lnR>
+                    <a:lnT w="6350" cap="flat" cmpd="sng" algn="ctr">
+                      <a:solidFill>
+                        <a:srgbClr val="D5DCE4"/>
+                      </a:solidFill>
+                      <a:prstDash val="solid"/>
+                      <a:round/>
+                      <a:headEnd type="none" w="med" len="med"/>
+                      <a:tailEnd type="none" w="med" len="med"/>
+                    </a:lnT>
+                    <a:lnB w="6350" cap="flat" cmpd="sng" algn="ctr">
+                      <a:solidFill>
+                        <a:srgbClr val="D5DCE4"/>
+                      </a:solidFill>
+                      <a:prstDash val="solid"/>
+                      <a:round/>
+                      <a:headEnd type="none" w="med" len="med"/>
+                      <a:tailEnd type="none" w="med" len="med"/>
+                    </a:lnB>
+                  </a:tcPr>
+                </a:tc>
+              </a:tr>
+              <a:tr h="713232">
+                <a:tc>
+                  <a:txBody>
+                    <a:bodyPr/>
+                    <a:lstStyle/>
+                    <a:p>
+                      <a:pPr indent="0" marL="0">
+                        <a:buNone/>
+                      </a:pPr>
+                      <a:r>
+                        <a:rPr lang="en-US" sz="950" b="1" dirty="0">
+                          <a:solidFill>
+                            <a:srgbClr val="003087"/>
+                          </a:solidFill>
+                          <a:latin typeface="Aptos" pitchFamily="34" charset="0"/>
+                          <a:ea typeface="Aptos" pitchFamily="34" charset="-122"/>
+                          <a:cs typeface="Aptos" pitchFamily="34" charset="-120"/>
+                        </a:rPr>
+                        <a:t>Achats saisonniers et fiscaux</a:t>
+                      </a:r>
+                      <a:endParaRPr lang="en-US" sz="950" dirty="0">
+                        <a:latin typeface="Aptos" charset="0"/>
+                        <a:ea typeface="Aptos" charset="0"/>
+                        <a:cs typeface="Aptos" charset="0"/>
+                      </a:endParaRPr>
+                    </a:p>
+                    <a:p>
+                      <a:pPr indent="0" marL="0">
+                        <a:buNone/>
+                      </a:pPr>
+                      <a:r>
+                        <a:rPr lang="en-US" sz="950" dirty="0">
+                          <a:solidFill>
+                            <a:srgbClr val="404040"/>
+                          </a:solidFill>
+                          <a:latin typeface="Aptos" pitchFamily="34" charset="0"/>
+                          <a:ea typeface="Aptos" pitchFamily="34" charset="-122"/>
+                          <a:cs typeface="Aptos" pitchFamily="34" charset="-120"/>
+                        </a:rPr>
+                        <a:t>Espagne, Italie, Andorre</a:t>
+                      </a:r>
+                      <a:endParaRPr lang="en-US" sz="950" dirty="0">
+                        <a:latin typeface="Aptos" charset="0"/>
+                        <a:ea typeface="Aptos" charset="0"/>
+                        <a:cs typeface="Aptos" charset="0"/>
+                      </a:endParaRPr>
+                    </a:p>
+                  </a:txBody>
+                  <a:tcPr marL="63500" marR="63500" marT="38100" marB="38100" anchor="ctr">
+                    <a:lnL w="6350" cap="flat" cmpd="sng" algn="ctr">
+                      <a:solidFill>
+                        <a:srgbClr val="D5DCE4"/>
+                      </a:solidFill>
+                      <a:prstDash val="solid"/>
+                      <a:round/>
+                      <a:headEnd type="none" w="med" len="med"/>
+                      <a:tailEnd type="none" w="med" len="med"/>
+                    </a:lnL>
+                    <a:lnR w="6350" cap="flat" cmpd="sng" algn="ctr">
+                      <a:solidFill>
+                        <a:srgbClr val="D5DCE4"/>
+                      </a:solidFill>
+                      <a:prstDash val="solid"/>
+                      <a:round/>
+                      <a:headEnd type="none" w="med" len="med"/>
+                      <a:tailEnd type="none" w="med" len="med"/>
+                    </a:lnR>
+                    <a:lnT w="6350" cap="flat" cmpd="sng" algn="ctr">
+                      <a:solidFill>
+                        <a:srgbClr val="D5DCE4"/>
+                      </a:solidFill>
+                      <a:prstDash val="solid"/>
+                      <a:round/>
+                      <a:headEnd type="none" w="med" len="med"/>
+                      <a:tailEnd type="none" w="med" len="med"/>
+                    </a:lnT>
+                    <a:lnB w="6350" cap="flat" cmpd="sng" algn="ctr">
+                      <a:solidFill>
+                        <a:srgbClr val="D5DCE4"/>
+                      </a:solidFill>
+                      <a:prstDash val="solid"/>
+                      <a:round/>
+                      <a:headEnd type="none" w="med" len="med"/>
+                      <a:tailEnd type="none" w="med" len="med"/>
+                    </a:lnB>
+                  </a:tcPr>
+                </a:tc>
+                <a:tc>
+                  <a:txBody>
+                    <a:bodyPr/>
+                    <a:lstStyle/>
+                    <a:p>
+                      <a:pPr indent="0" marL="0">
+                        <a:buNone/>
+                      </a:pPr>
+                      <a:r>
+                        <a:rPr lang="en-US" sz="950" dirty="0">
+                          <a:solidFill>
+                            <a:srgbClr val="404040"/>
+                          </a:solidFill>
+                          <a:latin typeface="Aptos" pitchFamily="34" charset="0"/>
+                          <a:ea typeface="Aptos" pitchFamily="34" charset="-122"/>
+                          <a:cs typeface="Aptos" pitchFamily="34" charset="-120"/>
+                        </a:rPr>
+                        <a:t>Jusqu'à 23 % des dépenses en juillet-août ; gros paniers de tabac (91 € par achat en Espagne) ; tabac en Italie +26 % en 2024</a:t>
+                      </a:r>
+                      <a:endParaRPr lang="en-US" sz="950" dirty="0">
+                        <a:latin typeface="Aptos" charset="0"/>
+                        <a:ea typeface="Aptos" charset="0"/>
+                        <a:cs typeface="Aptos" charset="0"/>
+                      </a:endParaRPr>
+                    </a:p>
+                  </a:txBody>
+                  <a:tcPr marL="63500" marR="63500" marT="38100" marB="38100" anchor="ctr">
+                    <a:lnL w="6350" cap="flat" cmpd="sng" algn="ctr">
+                      <a:solidFill>
+                        <a:srgbClr val="D5DCE4"/>
+                      </a:solidFill>
+                      <a:prstDash val="solid"/>
+                      <a:round/>
+                      <a:headEnd type="none" w="med" len="med"/>
+                      <a:tailEnd type="none" w="med" len="med"/>
+                    </a:lnL>
+                    <a:lnR w="6350" cap="flat" cmpd="sng" algn="ctr">
+                      <a:solidFill>
+                        <a:srgbClr val="D5DCE4"/>
+                      </a:solidFill>
+                      <a:prstDash val="solid"/>
+                      <a:round/>
+                      <a:headEnd type="none" w="med" len="med"/>
+                      <a:tailEnd type="none" w="med" len="med"/>
+                    </a:lnR>
+                    <a:lnT w="6350" cap="flat" cmpd="sng" algn="ctr">
+                      <a:solidFill>
+                        <a:srgbClr val="D5DCE4"/>
+                      </a:solidFill>
+                      <a:prstDash val="solid"/>
+                      <a:round/>
+                      <a:headEnd type="none" w="med" len="med"/>
+                      <a:tailEnd type="none" w="med" len="med"/>
+                    </a:lnT>
+                    <a:lnB w="6350" cap="flat" cmpd="sng" algn="ctr">
+                      <a:solidFill>
+                        <a:srgbClr val="D5DCE4"/>
+                      </a:solidFill>
+                      <a:prstDash val="solid"/>
+                      <a:round/>
+                      <a:headEnd type="none" w="med" len="med"/>
+                      <a:tailEnd type="none" w="med" len="med"/>
+                    </a:lnB>
+                  </a:tcPr>
+                </a:tc>
+              </a:tr>
+            </a:tbl>
+          </a:graphicData>
+        </a:graphic>
+      </p:graphicFrame>
+      <p:sp>
+        <p:nvSpPr>
+          <p:cNvPr id="8" name="Shape 5"/>
+          <p:cNvSpPr/>
+          <p:nvPr/>
+        </p:nvSpPr>
+        <p:spPr>
+          <a:xfrm>
+            <a:off x="365760" y="4069080"/>
+            <a:ext cx="5394960" cy="1874520"/>
+          </a:xfrm>
+          <a:prstGeom prst="rect">
+            <a:avLst/>
+          </a:prstGeom>
+          <a:solidFill>
+            <a:srgbClr val="EBF4FB"/>
+          </a:solidFill>
+          <a:ln w="12700">
+            <a:solidFill>
+              <a:srgbClr val="EBF4FB"/>
+            </a:solidFill>
+            <a:prstDash val="solid"/>
+          </a:ln>
+        </p:spPr>
+      </p:sp>
+      <p:sp>
+        <p:nvSpPr>
+          <p:cNvPr id="9" name="Text 6"/>
+          <p:cNvSpPr txBox="1"/>
+          <p:nvPr/>
+        </p:nvSpPr>
+        <p:spPr>
+          <a:xfrm>
+            <a:off x="502920" y="4133088"/>
+            <a:ext cx="5120640" cy="274320"/>
+          </a:xfrm>
+          <a:prstGeom prst="rect">
+            <a:avLst/>
+          </a:prstGeom>
+          <a:noFill/>
+          <a:ln/>
+        </p:spPr>
+        <p:txBody>
+          <a:bodyPr wrap="square" lIns="0" tIns="0" rIns="0" bIns="0" rtlCol="0" anchor="ctr"/>
+          <a:lstStyle/>
+          <a:p>
+            <a:pPr indent="0" marL="0">
+              <a:buNone/>
+            </a:pPr>
+            <a:r>
+              <a:rPr lang="en-US" sz="1150" b="1" dirty="0">
+                <a:solidFill>
+                  <a:srgbClr val="003087"/>
+                </a:solidFill>
+                <a:latin typeface="Aptos" pitchFamily="34" charset="0"/>
+                <a:ea typeface="Aptos" pitchFamily="34" charset="-122"/>
+                <a:cs typeface="Aptos" pitchFamily="34" charset="-120"/>
+              </a:rPr>
+              <a:t>Traces dans le tissu commercial local</a:t>
+            </a:r>
+            <a:endParaRPr lang="en-US" sz="1150" dirty="0"/>
+          </a:p>
+        </p:txBody>
+      </p:sp>
+      <p:sp>
+        <p:nvSpPr>
+          <p:cNvPr id="10" name="Text 7"/>
+          <p:cNvSpPr txBox="1"/>
+          <p:nvPr/>
+        </p:nvSpPr>
+        <p:spPr>
+          <a:xfrm>
+            <a:off x="502920" y="4434840"/>
+            <a:ext cx="5120640" cy="1463040"/>
+          </a:xfrm>
+          <a:prstGeom prst="rect">
+            <a:avLst/>
+          </a:prstGeom>
+          <a:noFill/>
+          <a:ln/>
+        </p:spPr>
+        <p:txBody>
+          <a:bodyPr wrap="square" lIns="0" tIns="0" rIns="0" bIns="0" rtlCol="0" anchor="t"/>
+          <a:lstStyle/>
+          <a:p>
+            <a:pPr marL="177800" indent="-177800">
+              <a:spcAft>
+                <a:spcPts val="500"/>
+              </a:spcAft>
+              <a:buSzPct val="100000"/>
+              <a:buChar char="•"/>
+            </a:pPr>
+            <a:r>
+              <a:rPr lang="en-US" sz="1050" dirty="0">
+                <a:solidFill>
+                  <a:srgbClr val="404040"/>
+                </a:solidFill>
+                <a:latin typeface="Aptos" pitchFamily="34" charset="0"/>
+                <a:ea typeface="Aptos" pitchFamily="34" charset="-122"/>
+                <a:cs typeface="Aptos" pitchFamily="34" charset="-120"/>
+              </a:rPr>
+              <a:t>À moins de 20 km de la frontière : 25 % de buralistes et 17 % de stations-service en moins par habitant (64 % et 57 % en moins face au Luxembourg).</a:t>
+            </a:r>
+            <a:endParaRPr lang="en-US" sz="1050" dirty="0"/>
+          </a:p>
+          <a:p>
+            <a:pPr marL="177800" indent="-177800">
+              <a:spcAft>
+                <a:spcPts val="500"/>
+              </a:spcAft>
+              <a:buSzPct val="100000"/>
+              <a:buChar char="•"/>
+            </a:pPr>
+            <a:r>
+              <a:rPr lang="en-US" sz="1050" dirty="0">
+                <a:solidFill>
+                  <a:srgbClr val="404040"/>
+                </a:solidFill>
+                <a:latin typeface="Aptos" pitchFamily="34" charset="0"/>
+                <a:ea typeface="Aptos" pitchFamily="34" charset="-122"/>
+                <a:cs typeface="Aptos" pitchFamily="34" charset="-120"/>
+              </a:rPr>
+              <a:t>6,7 créations d'entreprises du commerce, des transports et de l'hébergement par commune frontalière en 2024, contre 9,2 ailleurs.</a:t>
+            </a:r>
+            <a:endParaRPr lang="en-US" sz="1050" dirty="0"/>
+          </a:p>
+          <a:p>
+            <a:pPr marL="177800" indent="-177800">
+              <a:spcAft>
+                <a:spcPts val="500"/>
+              </a:spcAft>
+              <a:buSzPct val="100000"/>
+              <a:buChar char="•"/>
+            </a:pPr>
+            <a:r>
+              <a:rPr lang="en-US" sz="1050" dirty="0">
+                <a:solidFill>
+                  <a:srgbClr val="404040"/>
+                </a:solidFill>
+                <a:latin typeface="Aptos" pitchFamily="34" charset="0"/>
+                <a:ea typeface="Aptos" pitchFamily="34" charset="-122"/>
+                <a:cs typeface="Aptos" pitchFamily="34" charset="-120"/>
+              </a:rPr>
+              <a:t>La politique locale compte : à Thionville (Action Cœur de Ville), vacance commerciale −60 % en quatre ans.</a:t>
+            </a:r>
+            <a:endParaRPr lang="en-US" sz="1050" dirty="0"/>
+          </a:p>
+        </p:txBody>
+      </p:sp>
+      <p:sp>
+        <p:nvSpPr>
+          <p:cNvPr id="11" name="Text 8"/>
+          <p:cNvSpPr txBox="1"/>
+          <p:nvPr/>
+        </p:nvSpPr>
+        <p:spPr>
+          <a:xfrm>
+            <a:off x="5989320" y="1005840"/>
+            <a:ext cx="5852160" cy="365760"/>
+          </a:xfrm>
+          <a:prstGeom prst="rect">
+            <a:avLst/>
+          </a:prstGeom>
+          <a:noFill/>
+          <a:ln/>
+        </p:spPr>
+        <p:txBody>
+          <a:bodyPr wrap="square" lIns="0" tIns="0" rIns="0" bIns="0" rtlCol="0" anchor="b"/>
+          <a:lstStyle/>
+          <a:p>
+            <a:pPr indent="0" marL="0">
+              <a:buNone/>
+            </a:pPr>
+            <a:r>
+              <a:rPr lang="en-US" sz="1200" b="1" dirty="0">
+                <a:solidFill>
+                  <a:srgbClr val="404040"/>
+                </a:solidFill>
+                <a:latin typeface="Aptos" pitchFamily="34" charset="0"/>
+                <a:ea typeface="Aptos" pitchFamily="34" charset="-122"/>
+                <a:cs typeface="Aptos" pitchFamily="34" charset="-120"/>
+              </a:rPr>
+              <a:t>Politiques en place : une coopération dense, rarement tournée vers le commerce</a:t>
+            </a:r>
+            <a:endParaRPr lang="en-US" sz="1200" dirty="0"/>
+          </a:p>
+        </p:txBody>
+      </p:sp>
+      <p:graphicFrame>
+        <p:nvGraphicFramePr>
+          <p:cNvPr id="11" name="Table 1"/>
+          <p:cNvGraphicFramePr>
+            <a:graphicFrameLocks noGrp="1"/>
+          </p:cNvGraphicFramePr>
+          <p:nvPr>
+            <p:extLst>
+              <p:ext uri="{D42A27DB-BD31-4B8C-83A1-F6EECF244321}">
+                <p14:modId xmlns:p14="http://schemas.microsoft.com/office/powerpoint/2010/main" val="1579011935"/>
+              </p:ext>
+            </p:extLst>
+          </p:nvPr>
+        </p:nvGraphicFramePr>
+        <p:xfrm>
+          <a:off x="5989320" y="1417320"/>
+          <a:ext cx="5852160" cy="914400"/>
+        </p:xfrm>
+        <a:graphic>
+          <a:graphicData uri="http://schemas.openxmlformats.org/drawingml/2006/table">
+            <a:tbl>
+              <a:tblPr/>
+              <a:tblGrid>
+                <a:gridCol w="777240"/>
+                <a:gridCol w="2148840"/>
+                <a:gridCol w="2926080"/>
+              </a:tblGrid>
+              <a:tr h="301752">
+                <a:tc>
+                  <a:txBody>
+                    <a:bodyPr/>
+                    <a:lstStyle/>
+                    <a:p>
+                      <a:pPr indent="0" marL="0">
+                        <a:buNone/>
+                      </a:pPr>
+                      <a:r>
+                        <a:rPr lang="en-US" sz="950" b="1" dirty="0">
+                          <a:solidFill>
+                            <a:srgbClr val="FFFFFF"/>
+                          </a:solidFill>
+                          <a:latin typeface="Aptos" pitchFamily="34" charset="0"/>
+                          <a:ea typeface="Aptos" pitchFamily="34" charset="-122"/>
+                          <a:cs typeface="Aptos" pitchFamily="34" charset="-120"/>
+                        </a:rPr>
+                        <a:t>Niveau</a:t>
+                      </a:r>
+                      <a:endParaRPr lang="en-US" sz="950" dirty="0">
                         <a:latin typeface="Aptos" charset="0"/>
                         <a:ea typeface="Aptos" charset="0"/>
                         <a:cs typeface="Aptos" charset="0"/>
@@ -7365,7 +7762,7 @@
                         <a:buNone/>
                       </a:pPr>
                       <a:r>
-                        <a:rPr lang="en-US" sz="1000" b="1" dirty="0">
+                        <a:rPr lang="en-US" sz="950" b="1" dirty="0">
                           <a:solidFill>
                             <a:srgbClr val="FFFFFF"/>
                           </a:solidFill>
@@ -7373,9 +7770,77 @@
                           <a:ea typeface="Aptos" pitchFamily="34" charset="-122"/>
                           <a:cs typeface="Aptos" pitchFamily="34" charset="-120"/>
                         </a:rPr>
-                        <a:t>Ce qu'il fait pour le commerce frontalier</a:t>
+                        <a:t>Instrument</a:t>
                       </a:r>
-                      <a:endParaRPr lang="en-US" sz="1000" dirty="0">
+                      <a:endParaRPr lang="en-US" sz="950" dirty="0">
+                        <a:latin typeface="Aptos" charset="0"/>
+                        <a:ea typeface="Aptos" charset="0"/>
+                        <a:cs typeface="Aptos" charset="0"/>
+                      </a:endParaRPr>
+                    </a:p>
+                  </a:txBody>
+                  <a:tcPr marL="63500" marR="63500" marT="38100" marB="38100" anchor="ctr">
+                    <a:lnL w="6350" cap="flat" cmpd="sng" algn="ctr">
+                      <a:solidFill>
+                        <a:srgbClr val="D5DCE4"/>
+                      </a:solidFill>
+                      <a:prstDash val="solid"/>
+                      <a:round/>
+                      <a:headEnd type="none" w="med" len="med"/>
+                      <a:tailEnd type="none" w="med" len="med"/>
+                    </a:lnL>
+                    <a:lnR w="6350" cap="flat" cmpd="sng" algn="ctr">
+                      <a:solidFill>
+                        <a:srgbClr val="D5DCE4"/>
+                      </a:solidFill>
+                      <a:prstDash val="solid"/>
+                      <a:round/>
+                      <a:headEnd type="none" w="med" len="med"/>
+                      <a:tailEnd type="none" w="med" len="med"/>
+                    </a:lnR>
+                    <a:lnT w="6350" cap="flat" cmpd="sng" algn="ctr">
+                      <a:solidFill>
+                        <a:srgbClr val="D5DCE4"/>
+                      </a:solidFill>
+                      <a:prstDash val="solid"/>
+                      <a:round/>
+                      <a:headEnd type="none" w="med" len="med"/>
+                      <a:tailEnd type="none" w="med" len="med"/>
+                    </a:lnT>
+                    <a:lnB w="6350" cap="flat" cmpd="sng" algn="ctr">
+                      <a:solidFill>
+                        <a:srgbClr val="D5DCE4"/>
+                      </a:solidFill>
+                      <a:prstDash val="solid"/>
+                      <a:round/>
+                      <a:headEnd type="none" w="med" len="med"/>
+                      <a:tailEnd type="none" w="med" len="med"/>
+                    </a:lnB>
+                    <a:solidFill>
+                      <a:srgbClr val="0070C0"/>
+                    </a:solidFill>
+                  </a:tcPr>
+                </a:tc>
+                <a:tc>
+                  <a:txBody>
+                    <a:bodyPr/>
+                    <a:lstStyle/>
+                    <a:p>
+                      <a:pPr indent="0" marL="0">
+                        <a:buNone/>
+                      </a:pPr>
+                      <a:r>
+                        <a:rPr lang="en-US" sz="950" b="1" dirty="0">
+                          <a:solidFill>
+                            <a:srgbClr val="FFFFFF"/>
+                          </a:solidFill>
+                          <a:latin typeface="Aptos" pitchFamily="34" charset="0"/>
+                          <a:ea typeface="Aptos" pitchFamily="34" charset="-122"/>
+                          <a:cs typeface="Aptos" pitchFamily="34" charset="-120"/>
+                        </a:rPr>
+                        <a:t>Place du commerce</a:t>
+                      </a:r>
+                      <a:endParaRPr lang="en-US" sz="950" dirty="0">
                         <a:latin typeface="Aptos" charset="0"/>
                         <a:ea typeface="Aptos" charset="0"/>
                         <a:cs typeface="Aptos" charset="0"/>
@@ -7435,7 +7900,7 @@
                         <a:buNone/>
                       </a:pPr>
                       <a:r>
-                        <a:rPr lang="en-US" sz="1000" b="1" dirty="0">
+                        <a:rPr lang="en-US" sz="950" b="1" dirty="0">
                           <a:solidFill>
                             <a:srgbClr val="003087"/>
                           </a:solidFill>
@@ -7445,7 +7910,7 @@
                         </a:rPr>
                         <a:t>UE</a:t>
                       </a:r>
-                      <a:endParaRPr lang="en-US" sz="1000" dirty="0">
+                      <a:endParaRPr lang="en-US" sz="950" dirty="0">
                         <a:latin typeface="Aptos" charset="0"/>
                         <a:ea typeface="Aptos" charset="0"/>
                         <a:cs typeface="Aptos" charset="0"/>
@@ -7500,7 +7965,7 @@
                         <a:buNone/>
                       </a:pPr>
                       <a:r>
-                        <a:rPr lang="en-US" sz="1000" dirty="0">
+                        <a:rPr lang="en-US" sz="950" dirty="0">
                           <a:solidFill>
                             <a:srgbClr val="404040"/>
                           </a:solidFill>
@@ -7508,9 +7973,9 @@
                           <a:ea typeface="Aptos" pitchFamily="34" charset="-122"/>
                           <a:cs typeface="Aptos" pitchFamily="34" charset="-120"/>
                         </a:rPr>
-                        <a:t>Révision de la directive sur la taxation du tabac (proposition 2025)</a:t>
+                        <a:t>Interreg 2014–2020 (23 programmes, 3,02 Md€ de FEDER)</a:t>
                       </a:r>
-                      <a:endParaRPr lang="en-US" sz="1000" dirty="0">
+                      <a:endParaRPr lang="en-US" sz="950" dirty="0">
                         <a:latin typeface="Aptos" charset="0"/>
                         <a:ea typeface="Aptos" charset="0"/>
                         <a:cs typeface="Aptos" charset="0"/>
@@ -7565,7 +8030,7 @@
                         <a:buNone/>
                       </a:pPr>
                       <a:r>
-                        <a:rPr lang="en-US" sz="1000" dirty="0">
+                        <a:rPr lang="en-US" sz="950" dirty="0">
                           <a:solidFill>
                             <a:srgbClr val="404040"/>
                           </a:solidFill>
@@ -7573,9 +8038,9 @@
                           <a:ea typeface="Aptos" pitchFamily="34" charset="-122"/>
                           <a:cs typeface="Aptos" pitchFamily="34" charset="-120"/>
                         </a:rPr>
-                        <a:t>Relève les minima d'accises à partir de 2028 ; ne couvre ni Andorre ni la Suisse</a:t>
+                        <a:t>Indirecte : environ 7 % pour la compétitivité des PME ; le commerce n'est pas une priorité nommée</a:t>
                       </a:r>
-                      <a:endParaRPr lang="en-US" sz="1000" dirty="0">
+                      <a:endParaRPr lang="en-US" sz="950" dirty="0">
                         <a:latin typeface="Aptos" charset="0"/>
                         <a:ea typeface="Aptos" charset="0"/>
                         <a:cs typeface="Aptos" charset="0"/>
@@ -7632,7 +8097,7 @@
                         <a:buNone/>
                       </a:pPr>
                       <a:r>
-                        <a:rPr lang="en-US" sz="1000" b="1" dirty="0">
+                        <a:rPr lang="en-US" sz="950" b="1" dirty="0">
                           <a:solidFill>
                             <a:srgbClr val="003087"/>
                           </a:solidFill>
@@ -7642,7 +8107,7 @@
                         </a:rPr>
                         <a:t>UE</a:t>
                       </a:r>
-                      <a:endParaRPr lang="en-US" sz="1000" dirty="0">
+                      <a:endParaRPr lang="en-US" sz="950" dirty="0">
                         <a:latin typeface="Aptos" charset="0"/>
                         <a:ea typeface="Aptos" charset="0"/>
                         <a:cs typeface="Aptos" charset="0"/>
@@ -7697,7 +8162,7 @@
                         <a:buNone/>
                       </a:pPr>
                       <a:r>
-                        <a:rPr lang="en-US" sz="1000" dirty="0">
+                        <a:rPr lang="en-US" sz="950" dirty="0">
                           <a:solidFill>
                             <a:srgbClr val="404040"/>
                           </a:solidFill>
@@ -7705,9 +8170,9 @@
                           <a:ea typeface="Aptos" pitchFamily="34" charset="-122"/>
                           <a:cs typeface="Aptos" pitchFamily="34" charset="-120"/>
                         </a:rPr>
-                        <a:t>Interreg VI-A</a:t>
+                        <a:t>ESPON CROSSSHOP (déc. 2025–janv. 2027)</a:t>
                       </a:r>
-                      <a:endParaRPr lang="en-US" sz="1000" dirty="0">
+                      <a:endParaRPr lang="en-US" sz="950" dirty="0">
                         <a:latin typeface="Aptos" charset="0"/>
                         <a:ea typeface="Aptos" charset="0"/>
                         <a:cs typeface="Aptos" charset="0"/>
@@ -7762,7 +8227,7 @@
                         <a:buNone/>
                       </a:pPr>
                       <a:r>
-                        <a:rPr lang="en-US" sz="1000" dirty="0">
+                        <a:rPr lang="en-US" sz="950" dirty="0">
                           <a:solidFill>
                             <a:srgbClr val="404040"/>
                           </a:solidFill>
@@ -7770,9 +8235,9 @@
                           <a:ea typeface="Aptos" pitchFamily="34" charset="-122"/>
                           <a:cs typeface="Aptos" pitchFamily="34" charset="-120"/>
                         </a:rPr>
-                        <a:t>Numérisation des PME sur plusieurs frontières ; aucune priorité PME dans le programme Grande Région</a:t>
+                        <a:t>Première étude européenne dédiée aux achats transfrontaliers, sur la frontière franco-allemande</a:t>
                       </a:r>
-                      <a:endParaRPr lang="en-US" sz="1000" dirty="0">
+                      <a:endParaRPr lang="en-US" sz="950" dirty="0">
                         <a:latin typeface="Aptos" charset="0"/>
                         <a:ea typeface="Aptos" charset="0"/>
                         <a:cs typeface="Aptos" charset="0"/>
@@ -7829,7 +8294,7 @@
                         <a:buNone/>
                       </a:pPr>
                       <a:r>
-                        <a:rPr lang="en-US" sz="1000" b="1" dirty="0">
+                        <a:rPr lang="en-US" sz="950" b="1" dirty="0">
                           <a:solidFill>
                             <a:srgbClr val="003087"/>
                           </a:solidFill>
@@ -7837,9 +8302,9 @@
                           <a:ea typeface="Aptos" pitchFamily="34" charset="-122"/>
                           <a:cs typeface="Aptos" pitchFamily="34" charset="-120"/>
                         </a:rPr>
-                        <a:t>National</a:t>
+                        <a:t>UE</a:t>
                       </a:r>
-                      <a:endParaRPr lang="en-US" sz="1000" dirty="0">
+                      <a:endParaRPr lang="en-US" sz="950" dirty="0">
                         <a:latin typeface="Aptos" charset="0"/>
                         <a:ea typeface="Aptos" charset="0"/>
                         <a:cs typeface="Aptos" charset="0"/>
@@ -7894,7 +8359,7 @@
                         <a:buNone/>
                       </a:pPr>
                       <a:r>
-                        <a:rPr lang="en-US" sz="1000" dirty="0">
+                        <a:rPr lang="en-US" sz="950" dirty="0">
                           <a:solidFill>
                             <a:srgbClr val="404040"/>
                           </a:solidFill>
@@ -7902,9 +8367,9 @@
                           <a:ea typeface="Aptos" pitchFamily="34" charset="-122"/>
                           <a:cs typeface="Aptos" pitchFamily="34" charset="-120"/>
                         </a:rPr>
-                        <a:t>Protocole buralistes 2023–2027</a:t>
+                        <a:t>Règlement BRIDGEforEU (2025)</a:t>
                       </a:r>
-                      <a:endParaRPr lang="en-US" sz="1000" dirty="0">
+                      <a:endParaRPr lang="en-US" sz="950" dirty="0">
                         <a:latin typeface="Aptos" charset="0"/>
                         <a:ea typeface="Aptos" charset="0"/>
                         <a:cs typeface="Aptos" charset="0"/>
@@ -7959,7 +8424,7 @@
                         <a:buNone/>
                       </a:pPr>
                       <a:r>
-                        <a:rPr lang="en-US" sz="1000" dirty="0">
+                        <a:rPr lang="en-US" sz="950" dirty="0">
                           <a:solidFill>
                             <a:srgbClr val="404040"/>
                           </a:solidFill>
@@ -7967,9 +8432,9 @@
                           <a:ea typeface="Aptos" pitchFamily="34" charset="-122"/>
                           <a:cs typeface="Aptos" pitchFamily="34" charset="-120"/>
                         </a:rPr>
-                        <a:t>Transformation jusqu'à 33 000 € ; prime de diversification portée à 2 500 € dans les départements frontaliers</a:t>
+                        <a:t>Points de coordination pour lever les obstacles juridiques ; l'ANCT est le point national</a:t>
                       </a:r>
-                      <a:endParaRPr lang="en-US" sz="1000" dirty="0">
+                      <a:endParaRPr lang="en-US" sz="950" dirty="0">
                         <a:latin typeface="Aptos" charset="0"/>
                         <a:ea typeface="Aptos" charset="0"/>
                         <a:cs typeface="Aptos" charset="0"/>
@@ -8016,7 +8481,7 @@
                   </a:tcPr>
                 </a:tc>
               </a:tr>
-              <a:tr h="566928">
+              <a:tr h="530352">
                 <a:tc>
                   <a:txBody>
                     <a:bodyPr/>
@@ -8026,7 +8491,7 @@
                         <a:buNone/>
                       </a:pPr>
                       <a:r>
-                        <a:rPr lang="en-US" sz="1000" b="1" dirty="0">
+                        <a:rPr lang="en-US" sz="950" b="1" dirty="0">
                           <a:solidFill>
                             <a:srgbClr val="003087"/>
                           </a:solidFill>
@@ -8034,9 +8499,9 @@
                           <a:ea typeface="Aptos" pitchFamily="34" charset="-122"/>
                           <a:cs typeface="Aptos" pitchFamily="34" charset="-120"/>
                         </a:rPr>
-                        <a:t>National</a:t>
+                        <a:t>UE</a:t>
                       </a:r>
-                      <a:endParaRPr lang="en-US" sz="1000" dirty="0">
+                      <a:endParaRPr lang="en-US" sz="950" dirty="0">
                         <a:latin typeface="Aptos" charset="0"/>
                         <a:ea typeface="Aptos" charset="0"/>
                         <a:cs typeface="Aptos" charset="0"/>
@@ -8091,7 +8556,7 @@
                         <a:buNone/>
                       </a:pPr>
                       <a:r>
-                        <a:rPr lang="en-US" sz="1000" dirty="0">
+                        <a:rPr lang="en-US" sz="950" dirty="0">
                           <a:solidFill>
                             <a:srgbClr val="404040"/>
                           </a:solidFill>
@@ -8099,9 +8564,9 @@
                           <a:ea typeface="Aptos" pitchFamily="34" charset="-122"/>
                           <a:cs typeface="Aptos" pitchFamily="34" charset="-120"/>
                         </a:rPr>
-                        <a:t>Douane, règles 2024</a:t>
+                        <a:t>Révision de la directive tabac (proposition 2025)</a:t>
                       </a:r>
-                      <a:endParaRPr lang="en-US" sz="1000" dirty="0">
+                      <a:endParaRPr lang="en-US" sz="950" dirty="0">
                         <a:latin typeface="Aptos" charset="0"/>
                         <a:ea typeface="Aptos" charset="0"/>
                         <a:cs typeface="Aptos" charset="0"/>
@@ -8156,7 +8621,7 @@
                         <a:buNone/>
                       </a:pPr>
                       <a:r>
-                        <a:rPr lang="en-US" sz="1000" dirty="0">
+                        <a:rPr lang="en-US" sz="950" dirty="0">
                           <a:solidFill>
                             <a:srgbClr val="404040"/>
                           </a:solidFill>
@@ -8164,9 +8629,9 @@
                           <a:ea typeface="Aptos" pitchFamily="34" charset="-122"/>
                           <a:cs typeface="Aptos" pitchFamily="34" charset="-120"/>
                         </a:rPr>
-                        <a:t>12 critères pour qualifier un achat de tabac à l'étranger de commercial, dès une cartouche</a:t>
+                        <a:t>Minima d'accises relevés à partir de 2028 ; ni Andorre ni la Suisse</a:t>
                       </a:r>
-                      <a:endParaRPr lang="en-US" sz="1000" dirty="0">
+                      <a:endParaRPr lang="en-US" sz="950" dirty="0">
                         <a:latin typeface="Aptos" charset="0"/>
                         <a:ea typeface="Aptos" charset="0"/>
                         <a:cs typeface="Aptos" charset="0"/>
@@ -8213,7 +8678,7 @@
                   </a:tcPr>
                 </a:tc>
               </a:tr>
-              <a:tr h="566928">
+              <a:tr h="530352">
                 <a:tc>
                   <a:txBody>
                     <a:bodyPr/>
@@ -8223,7 +8688,7 @@
                         <a:buNone/>
                       </a:pPr>
                       <a:r>
-                        <a:rPr lang="en-US" sz="1000" b="1" dirty="0">
+                        <a:rPr lang="en-US" sz="950" b="1" dirty="0">
                           <a:solidFill>
                             <a:srgbClr val="003087"/>
                           </a:solidFill>
@@ -8233,7 +8698,7 @@
                         </a:rPr>
                         <a:t>National</a:t>
                       </a:r>
-                      <a:endParaRPr lang="en-US" sz="1000" dirty="0">
+                      <a:endParaRPr lang="en-US" sz="950" dirty="0">
                         <a:latin typeface="Aptos" charset="0"/>
                         <a:ea typeface="Aptos" charset="0"/>
                         <a:cs typeface="Aptos" charset="0"/>
@@ -8288,7 +8753,7 @@
                         <a:buNone/>
                       </a:pPr>
                       <a:r>
-                        <a:rPr lang="en-US" sz="1000" dirty="0">
+                        <a:rPr lang="en-US" sz="950" dirty="0">
                           <a:solidFill>
                             <a:srgbClr val="404040"/>
                           </a:solidFill>
@@ -8296,9 +8761,9 @@
                           <a:ea typeface="Aptos" pitchFamily="34" charset="-122"/>
                           <a:cs typeface="Aptos" pitchFamily="34" charset="-120"/>
                         </a:rPr>
-                        <a:t>Loi 3DS (2022)</a:t>
+                        <a:t>Protocole buralistes 2023–2027</a:t>
                       </a:r>
-                      <a:endParaRPr lang="en-US" sz="1000" dirty="0">
+                      <a:endParaRPr lang="en-US" sz="950" dirty="0">
                         <a:latin typeface="Aptos" charset="0"/>
                         <a:ea typeface="Aptos" charset="0"/>
                         <a:cs typeface="Aptos" charset="0"/>
@@ -8353,7 +8818,7 @@
                         <a:buNone/>
                       </a:pPr>
                       <a:r>
-                        <a:rPr lang="en-US" sz="1000" dirty="0">
+                        <a:rPr lang="en-US" sz="950" dirty="0">
                           <a:solidFill>
                             <a:srgbClr val="404040"/>
                           </a:solidFill>
@@ -8361,9 +8826,9 @@
                           <a:ea typeface="Aptos" pitchFamily="34" charset="-122"/>
                           <a:cs typeface="Aptos" pitchFamily="34" charset="-120"/>
                         </a:rPr>
-                        <a:t>Permet d'associer les communes étrangères voisines aux CDAC</a:t>
+                        <a:t>Prime de diversification portée à 2 500 € dans les départements frontaliers</a:t>
                       </a:r>
-                      <a:endParaRPr lang="en-US" sz="1000" dirty="0">
+                      <a:endParaRPr lang="en-US" sz="950" dirty="0">
                         <a:latin typeface="Aptos" charset="0"/>
                         <a:ea typeface="Aptos" charset="0"/>
                         <a:cs typeface="Aptos" charset="0"/>
@@ -8410,7 +8875,7 @@
                   </a:tcPr>
                 </a:tc>
               </a:tr>
-              <a:tr h="566928">
+              <a:tr h="530352">
                 <a:tc>
                   <a:txBody>
                     <a:bodyPr/>
@@ -8420,7 +8885,7 @@
                         <a:buNone/>
                       </a:pPr>
                       <a:r>
-                        <a:rPr lang="en-US" sz="1000" b="1" dirty="0">
+                        <a:rPr lang="en-US" sz="950" b="1" dirty="0">
                           <a:solidFill>
                             <a:srgbClr val="003087"/>
                           </a:solidFill>
@@ -8428,9 +8893,9 @@
                           <a:ea typeface="Aptos" pitchFamily="34" charset="-122"/>
                           <a:cs typeface="Aptos" pitchFamily="34" charset="-120"/>
                         </a:rPr>
-                        <a:t>Constat</a:t>
+                        <a:t>National</a:t>
                       </a:r>
-                      <a:endParaRPr lang="en-US" sz="1000" dirty="0">
+                      <a:endParaRPr lang="en-US" sz="950" dirty="0">
                         <a:latin typeface="Aptos" charset="0"/>
                         <a:ea typeface="Aptos" charset="0"/>
                         <a:cs typeface="Aptos" charset="0"/>
@@ -8485,7 +8950,7 @@
                         <a:buNone/>
                       </a:pPr>
                       <a:r>
-                        <a:rPr lang="en-US" sz="1000" dirty="0">
+                        <a:rPr lang="en-US" sz="950" dirty="0">
                           <a:solidFill>
                             <a:srgbClr val="404040"/>
                           </a:solidFill>
@@ -8493,9 +8958,9 @@
                           <a:ea typeface="Aptos" pitchFamily="34" charset="-122"/>
                           <a:cs typeface="Aptos" pitchFamily="34" charset="-120"/>
                         </a:rPr>
-                        <a:t>Action Cœur de Ville, Petites villes de demain, FRR</a:t>
+                        <a:t>Action Cœur de Ville, Petites villes de demain</a:t>
                       </a:r>
-                      <a:endParaRPr lang="en-US" sz="1000" dirty="0">
+                      <a:endParaRPr lang="en-US" sz="950" dirty="0">
                         <a:latin typeface="Aptos" charset="0"/>
                         <a:ea typeface="Aptos" charset="0"/>
                         <a:cs typeface="Aptos" charset="0"/>
@@ -8550,7 +9015,7 @@
                         <a:buNone/>
                       </a:pPr>
                       <a:r>
-                        <a:rPr lang="en-US" sz="1000" b="1" dirty="0">
+                        <a:rPr lang="en-US" sz="950" b="1" dirty="0">
                           <a:solidFill>
                             <a:srgbClr val="D9822B"/>
                           </a:solidFill>
@@ -8558,9 +9023,9 @@
                           <a:ea typeface="Aptos" pitchFamily="34" charset="-122"/>
                           <a:cs typeface="Aptos" pitchFamily="34" charset="-120"/>
                         </a:rPr>
-                        <a:t>Aucun critère d'exposition frontalière ; pas de mesure officielle des achats transfrontaliers</a:t>
+                        <a:t>Aucun critère frontalier ; volet commerce renforcé prévu après 2026</a:t>
                       </a:r>
-                      <a:endParaRPr lang="en-US" sz="1000" dirty="0">
+                      <a:endParaRPr lang="en-US" sz="950" dirty="0">
                         <a:latin typeface="Aptos" charset="0"/>
                         <a:ea typeface="Aptos" charset="0"/>
                         <a:cs typeface="Aptos" charset="0"/>
@@ -8607,13 +9072,210 @@
                   </a:tcPr>
                 </a:tc>
               </a:tr>
+              <a:tr h="658368">
+                <a:tc>
+                  <a:txBody>
+                    <a:bodyPr/>
+                    <a:lstStyle/>
+                    <a:p>
+                      <a:pPr indent="0" marL="0">
+                        <a:buNone/>
+                      </a:pPr>
+                      <a:r>
+                        <a:rPr lang="en-US" sz="950" b="1" dirty="0">
+                          <a:solidFill>
+                            <a:srgbClr val="003087"/>
+                          </a:solidFill>
+                          <a:latin typeface="Aptos" pitchFamily="34" charset="0"/>
+                          <a:ea typeface="Aptos" pitchFamily="34" charset="-122"/>
+                          <a:cs typeface="Aptos" pitchFamily="34" charset="-120"/>
+                        </a:rPr>
+                        <a:t>Local</a:t>
+                      </a:r>
+                      <a:endParaRPr lang="en-US" sz="950" dirty="0">
+                        <a:latin typeface="Aptos" charset="0"/>
+                        <a:ea typeface="Aptos" charset="0"/>
+                        <a:cs typeface="Aptos" charset="0"/>
+                      </a:endParaRPr>
+                    </a:p>
+                  </a:txBody>
+                  <a:tcPr marL="63500" marR="63500" marT="38100" marB="38100" anchor="ctr">
+                    <a:lnL w="6350" cap="flat" cmpd="sng" algn="ctr">
+                      <a:solidFill>
+                        <a:srgbClr val="D5DCE4"/>
+                      </a:solidFill>
+                      <a:prstDash val="solid"/>
+                      <a:round/>
+                      <a:headEnd type="none" w="med" len="med"/>
+                      <a:tailEnd type="none" w="med" len="med"/>
+                    </a:lnL>
+                    <a:lnR w="6350" cap="flat" cmpd="sng" algn="ctr">
+                      <a:solidFill>
+                        <a:srgbClr val="D5DCE4"/>
+                      </a:solidFill>
+                      <a:prstDash val="solid"/>
+                      <a:round/>
+                      <a:headEnd type="none" w="med" len="med"/>
+                      <a:tailEnd type="none" w="med" len="med"/>
+                    </a:lnR>
+                    <a:lnT w="6350" cap="flat" cmpd="sng" algn="ctr">
+                      <a:solidFill>
+                        <a:srgbClr val="D5DCE4"/>
+                      </a:solidFill>
+                      <a:prstDash val="solid"/>
+                      <a:round/>
+                      <a:headEnd type="none" w="med" len="med"/>
+                      <a:tailEnd type="none" w="med" len="med"/>
+                    </a:lnT>
+                    <a:lnB w="6350" cap="flat" cmpd="sng" algn="ctr">
+                      <a:solidFill>
+                        <a:srgbClr val="D5DCE4"/>
+                      </a:solidFill>
+                      <a:prstDash val="solid"/>
+                      <a:round/>
+                      <a:headEnd type="none" w="med" len="med"/>
+                      <a:tailEnd type="none" w="med" len="med"/>
+                    </a:lnB>
+                  </a:tcPr>
+                </a:tc>
+                <a:tc>
+                  <a:txBody>
+                    <a:bodyPr/>
+                    <a:lstStyle/>
+                    <a:p>
+                      <a:pPr indent="0" marL="0">
+                        <a:buNone/>
+                      </a:pPr>
+                      <a:r>
+                        <a:rPr lang="en-US" sz="950" dirty="0">
+                          <a:solidFill>
+                            <a:srgbClr val="404040"/>
+                          </a:solidFill>
+                          <a:latin typeface="Aptos" pitchFamily="34" charset="0"/>
+                          <a:ea typeface="Aptos" pitchFamily="34" charset="-122"/>
+                          <a:cs typeface="Aptos" pitchFamily="34" charset="-120"/>
+                        </a:rPr>
+                        <a:t>COMMERCE! (Interreg France-Wallonie-Vlaanderen), Business Twin (Rhin supérieur)</a:t>
+                      </a:r>
+                      <a:endParaRPr lang="en-US" sz="950" dirty="0">
+                        <a:latin typeface="Aptos" charset="0"/>
+                        <a:ea typeface="Aptos" charset="0"/>
+                        <a:cs typeface="Aptos" charset="0"/>
+                      </a:endParaRPr>
+                    </a:p>
+                  </a:txBody>
+                  <a:tcPr marL="63500" marR="63500" marT="38100" marB="38100" anchor="ctr">
+                    <a:lnL w="6350" cap="flat" cmpd="sng" algn="ctr">
+                      <a:solidFill>
+                        <a:srgbClr val="D5DCE4"/>
+                      </a:solidFill>
+                      <a:prstDash val="solid"/>
+                      <a:round/>
+                      <a:headEnd type="none" w="med" len="med"/>
+                      <a:tailEnd type="none" w="med" len="med"/>
+                    </a:lnL>
+                    <a:lnR w="6350" cap="flat" cmpd="sng" algn="ctr">
+                      <a:solidFill>
+                        <a:srgbClr val="D5DCE4"/>
+                      </a:solidFill>
+                      <a:prstDash val="solid"/>
+                      <a:round/>
+                      <a:headEnd type="none" w="med" len="med"/>
+                      <a:tailEnd type="none" w="med" len="med"/>
+                    </a:lnR>
+                    <a:lnT w="6350" cap="flat" cmpd="sng" algn="ctr">
+                      <a:solidFill>
+                        <a:srgbClr val="D5DCE4"/>
+                      </a:solidFill>
+                      <a:prstDash val="solid"/>
+                      <a:round/>
+                      <a:headEnd type="none" w="med" len="med"/>
+                      <a:tailEnd type="none" w="med" len="med"/>
+                    </a:lnT>
+                    <a:lnB w="6350" cap="flat" cmpd="sng" algn="ctr">
+                      <a:solidFill>
+                        <a:srgbClr val="D5DCE4"/>
+                      </a:solidFill>
+                      <a:prstDash val="solid"/>
+                      <a:round/>
+                      <a:headEnd type="none" w="med" len="med"/>
+                      <a:tailEnd type="none" w="med" len="med"/>
+                    </a:lnB>
+                  </a:tcPr>
+                </a:tc>
+                <a:tc>
+                  <a:txBody>
+                    <a:bodyPr/>
+                    <a:lstStyle/>
+                    <a:p>
+                      <a:pPr indent="0" marL="0">
+                        <a:buNone/>
+                      </a:pPr>
+                      <a:r>
+                        <a:rPr lang="en-US" sz="950" dirty="0">
+                          <a:solidFill>
+                            <a:srgbClr val="404040"/>
+                          </a:solidFill>
+                          <a:latin typeface="Aptos" pitchFamily="34" charset="0"/>
+                          <a:ea typeface="Aptos" pitchFamily="34" charset="-122"/>
+                          <a:cs typeface="Aptos" pitchFamily="34" charset="-120"/>
+                        </a:rPr>
+                        <a:t>Projets ciblés sur les commerçants ; l'Eurodistrict SaarMoselle s'oppose en 2025 à l'extension du FOC de Zweibrücken</a:t>
+                      </a:r>
+                      <a:endParaRPr lang="en-US" sz="950" dirty="0">
+                        <a:latin typeface="Aptos" charset="0"/>
+                        <a:ea typeface="Aptos" charset="0"/>
+                        <a:cs typeface="Aptos" charset="0"/>
+                      </a:endParaRPr>
+                    </a:p>
+                  </a:txBody>
+                  <a:tcPr marL="63500" marR="63500" marT="38100" marB="38100" anchor="ctr">
+                    <a:lnL w="6350" cap="flat" cmpd="sng" algn="ctr">
+                      <a:solidFill>
+                        <a:srgbClr val="D5DCE4"/>
+                      </a:solidFill>
+                      <a:prstDash val="solid"/>
+                      <a:round/>
+                      <a:headEnd type="none" w="med" len="med"/>
+                      <a:tailEnd type="none" w="med" len="med"/>
+                    </a:lnL>
+                    <a:lnR w="6350" cap="flat" cmpd="sng" algn="ctr">
+                      <a:solidFill>
+                        <a:srgbClr val="D5DCE4"/>
+                      </a:solidFill>
+                      <a:prstDash val="solid"/>
+                      <a:round/>
+                      <a:headEnd type="none" w="med" len="med"/>
+                      <a:tailEnd type="none" w="med" len="med"/>
+                    </a:lnR>
+                    <a:lnT w="6350" cap="flat" cmpd="sng" algn="ctr">
+                      <a:solidFill>
+                        <a:srgbClr val="D5DCE4"/>
+                      </a:solidFill>
+                      <a:prstDash val="solid"/>
+                      <a:round/>
+                      <a:headEnd type="none" w="med" len="med"/>
+                      <a:tailEnd type="none" w="med" len="med"/>
+                    </a:lnT>
+                    <a:lnB w="6350" cap="flat" cmpd="sng" algn="ctr">
+                      <a:solidFill>
+                        <a:srgbClr val="D5DCE4"/>
+                      </a:solidFill>
+                      <a:prstDash val="solid"/>
+                      <a:round/>
+                      <a:headEnd type="none" w="med" len="med"/>
+                      <a:tailEnd type="none" w="med" len="med"/>
+                    </a:lnB>
+                  </a:tcPr>
+                </a:tc>
+              </a:tr>
             </a:tbl>
           </a:graphicData>
         </a:graphic>
       </p:graphicFrame>
       <p:sp>
         <p:nvSpPr>
-          <p:cNvPr id="10" name="Text 6"/>
+          <p:cNvPr id="13" name="Text 9"/>
           <p:cNvSpPr txBox="1"/>
           <p:nvPr/>
         </p:nvSpPr>
@@ -8644,24 +9306,7 @@
                 <a:ea typeface="Aptos" pitchFamily="34" charset="-122"/>
                 <a:cs typeface="Aptos" pitchFamily="34" charset="-120"/>
               </a:rPr>
-              <a:t>Note : densités pour 10 000 habitants, communes à moins de 20 km d'une frontière terrestre ; buralistes : annuaire 2018 ; emploi : secteur privé, NAF 47.</a:t>
-            </a:r>
-            <a:endParaRPr lang="en-US" sz="900" dirty="0"/>
-          </a:p>
-          <a:p>
-            <a:pPr indent="0" marL="0">
-              <a:buNone/>
-            </a:pPr>
-            <a:r>
-              <a:rPr lang="en-US" sz="900" i="1" dirty="0">
-                <a:solidFill>
-                  <a:srgbClr val="727272"/>
-                </a:solidFill>
-                <a:latin typeface="Aptos" pitchFamily="34" charset="0"/>
-                <a:ea typeface="Aptos" pitchFamily="34" charset="-122"/>
-                <a:cs typeface="Aptos" pitchFamily="34" charset="-120"/>
-              </a:rPr>
-              <a:t>Sources : calculs des auteurs d'après Insee, BPE 2025 et populations de référence 2023 ; DGDDI (2018, 2024) ; Urssaf ; Commission européenne, COM(2025) 580 ; Interact (2026) ; ministère de l'Économie (2023), protocole buralistes ; loi n° 2022-217 (3DS).</a:t>
+              <a:t>Sources : Ast et Bichler (2025), Insee Première n° 2075 ; Insee, recensement 2022 ; calculs des auteurs d'après Insee, BPE 2025, et DGDDI (2018) ; Insee, SIDE 2024 ; ANCT (2025), bilan Interreg 2014–2020 ; Euro-Institut (2025) ; règlement (UE) 2025/925 ; COM(2025) 580 ; ministère de l'Économie (2023) ; CCI Alsace Eurométropole ; Eurodistrict SaarMoselle (2025).</a:t>
             </a:r>
             <a:endParaRPr lang="en-US" sz="900" dirty="0"/>
           </a:p>
@@ -9220,7 +9865,7 @@
               <a:buChar char="•"/>
             </a:pPr>
             <a:r>
-              <a:rPr lang="en-US" sz="1300" b="1" dirty="0">
+              <a:rPr lang="en-US" sz="1200" b="1" dirty="0">
                 <a:solidFill>
                   <a:srgbClr val="003087"/>
                 </a:solidFill>
@@ -9237,7 +9882,7 @@
               <a:buNone/>
             </a:pPr>
             <a:r>
-              <a:rPr lang="en-US" sz="1300" dirty="0">
+              <a:rPr lang="en-US" sz="1200" dirty="0">
                 <a:solidFill>
                   <a:srgbClr val="404040"/>
                 </a:solidFill>
@@ -9247,7 +9892,7 @@
               </a:rPr>
               <a:t>entre 2016 et 2022, l'emploi salarié des points de vente progresse de 1,6 % par an dans les pôles périphériques, contre 1,1 % dans les pôles de centre-ville ; la périphérie porte 40 % des créations d'emplois, les centres-villes 28 %.</a:t>
             </a:r>
-            <a:endParaRPr lang="en-US" sz="1300" dirty="0"/>
+            <a:endParaRPr lang="en-US" sz="1200" dirty="0"/>
           </a:p>
           <a:p>
             <a:pPr marL="177800" indent="-177800">
@@ -9258,7 +9903,7 @@
               <a:buChar char="•"/>
             </a:pPr>
             <a:r>
-              <a:rPr lang="en-US" sz="1300" b="1" dirty="0">
+              <a:rPr lang="en-US" sz="1200" b="1" dirty="0">
                 <a:solidFill>
                   <a:srgbClr val="003087"/>
                 </a:solidFill>
@@ -9275,7 +9920,7 @@
               <a:buNone/>
             </a:pPr>
             <a:r>
-              <a:rPr lang="en-US" sz="1300" dirty="0">
+              <a:rPr lang="en-US" sz="1200" dirty="0">
                 <a:solidFill>
                   <a:srgbClr val="404040"/>
                 </a:solidFill>
@@ -9285,7 +9930,7 @@
               </a:rPr>
               <a:t>un point de vente compte en moyenne 12 salariés et 586 m² en périphérie, contre 3 salariés et 92 m² en centre-ville.</a:t>
             </a:r>
-            <a:endParaRPr lang="en-US" sz="1300" dirty="0"/>
+            <a:endParaRPr lang="en-US" sz="1200" dirty="0"/>
           </a:p>
           <a:p>
             <a:pPr marL="177800" indent="-177800">
@@ -9296,7 +9941,7 @@
               <a:buChar char="•"/>
             </a:pPr>
             <a:r>
-              <a:rPr lang="en-US" sz="1300" b="1" dirty="0">
+              <a:rPr lang="en-US" sz="1200" b="1" dirty="0">
                 <a:solidFill>
                   <a:srgbClr val="003087"/>
                 </a:solidFill>
@@ -9313,7 +9958,7 @@
               <a:buNone/>
             </a:pPr>
             <a:r>
-              <a:rPr lang="en-US" sz="1300" dirty="0">
+              <a:rPr lang="en-US" sz="1200" dirty="0">
                 <a:solidFill>
                   <a:srgbClr val="404040"/>
                 </a:solidFill>
@@ -9323,7 +9968,45 @@
               </a:rPr>
               <a:t>la périphérie reste la mieux placée (8,4 %) face aux centres-villes (11,7 %) et aux centres commerciaux (16,8 %), mais l'écart se réduit.</a:t>
             </a:r>
-            <a:endParaRPr lang="en-US" sz="1300" dirty="0"/>
+            <a:endParaRPr lang="en-US" sz="1200" dirty="0"/>
+          </a:p>
+          <a:p>
+            <a:pPr marL="177800" indent="-177800">
+              <a:spcAft>
+                <a:spcPts val="500"/>
+              </a:spcAft>
+              <a:buSzPct val="100000"/>
+              <a:buChar char="•"/>
+            </a:pPr>
+            <a:r>
+              <a:rPr lang="en-US" sz="1200" b="1" dirty="0">
+                <a:solidFill>
+                  <a:srgbClr val="003087"/>
+                </a:solidFill>
+                <a:latin typeface="Aptos" pitchFamily="34" charset="0"/>
+                <a:ea typeface="Aptos" pitchFamily="34" charset="-122"/>
+                <a:cs typeface="Aptos" pitchFamily="34" charset="-120"/>
+              </a:rPr>
+              <a:t>Préférence déclarée : </a:t>
+            </a:r>
+            <a:pPr indent="0" marL="0">
+              <a:spcAft>
+                <a:spcPts val="500"/>
+              </a:spcAft>
+              <a:buNone/>
+            </a:pPr>
+            <a:r>
+              <a:rPr lang="en-US" sz="1200" dirty="0">
+                <a:solidFill>
+                  <a:srgbClr val="404040"/>
+                </a:solidFill>
+                <a:latin typeface="Aptos" pitchFamily="34" charset="0"/>
+                <a:ea typeface="Aptos" pitchFamily="34" charset="-122"/>
+                <a:cs typeface="Aptos" pitchFamily="34" charset="-120"/>
+              </a:rPr>
+              <a:t>62 % des Français disent privilégier les zones commerciales pour leurs achats, loisirs et services ; les centres-villes progressent entre 2023 et 2025.</a:t>
+            </a:r>
+            <a:endParaRPr lang="en-US" sz="1200" dirty="0"/>
           </a:p>
         </p:txBody>
       </p:sp>
@@ -9377,7 +10060,7 @@
                 <a:ea typeface="Aptos" pitchFamily="34" charset="-122"/>
                 <a:cs typeface="Aptos" pitchFamily="34" charset="-120"/>
               </a:rPr>
-              <a:t>Sources : Rexecode, d'après Insee, Procos et Fevad (2024) ; Cerema (2023), géolocalisation des zones commerciales ; Gouvernement (2023), dossier de presse « Un nouvel horizon pour les zones commerciales » ; Bloch et Pichavant (2026), Insee Première n° 2091 ; Codata (2026).</a:t>
+              <a:t>Sources : Rexecode, d'après Insee, Procos et Fevad (2024) ; Cerema (2023), géolocalisation des zones commerciales ; Gouvernement (2023), dossier de presse « Un nouvel horizon pour les zones commerciales » ; Bloch et Pichavant (2026), Insee Première n° 2091 ; Codata (2026) ; CNC (2026), d'après Ifop pour l'ANCT et la Banque des Territoires.</a:t>
             </a:r>
             <a:endParaRPr lang="en-US" sz="900" dirty="0"/>
           </a:p>

</xml_diff>

<commit_message>
Replace border bar chart with département map of spending abroad (Insee Première 2075)
Co-Authored-By: Claude Opus 5.5 <noreply@anthropic.com>
Claude-Session: https://claude.ai/code/session_01FJbXnypcpDe1GWB1d6YYfb
</commit_message>
<xml_diff>
--- a/cross_border/report_docx/Commerce_detail_France_DGE_DGGROW_7slides.pptx
+++ b/cross_border/report_docx/Commerce_detail_France_DGE_DGGROW_7slides.pptx
@@ -2124,291 +2124,6 @@
 </file>
 
 <file path=ppt/charts/chart4.xml><?xml version="1.0" encoding="utf-8"?>
-<c:chartSpace xmlns:c="http://schemas.openxmlformats.org/drawingml/2006/chart" xmlns:a="http://schemas.openxmlformats.org/drawingml/2006/main" xmlns:r="http://schemas.openxmlformats.org/officeDocument/2006/relationships">
-  <c:date1904 val="0"/>
-  <c:roundedCorners val="1"/>
-  <c:chart>
-    <c:autoTitleDeleted val="1"/>
-    <c:plotArea>
-      <c:layout/>
-      <c:barChart>
-        <c:barDir val="bar"/>
-        <c:grouping val="clustered"/>
-        <c:varyColors val="0"/>
-        <c:ser>
-          <c:idx val="0"/>
-          <c:order val="0"/>
-          <c:tx>
-            <c:strRef>
-              <c:f>Sheet1!$B$1</c:f>
-              <c:strCache>
-                <c:ptCount val="1"/>
-                <c:pt idx="0">
-                  <c:v>%</c:v>
-                </c:pt>
-              </c:strCache>
-            </c:strRef>
-          </c:tx>
-          <c:spPr>
-            <a:solidFill>
-              <a:srgbClr val="003087"/>
-            </a:solidFill>
-            <a:effectLst/>
-          </c:spPr>
-          <c:invertIfNegative val="0"/>
-          <c:dLbls>
-            <c:numFmt formatCode="0.0" sourceLinked="0"/>
-            <c:txPr>
-              <a:bodyPr/>
-              <a:lstStyle/>
-              <a:p>
-                <a:pPr>
-                  <a:defRPr b="1" i="0" strike="noStrike" sz="1000" u="none">
-                    <a:solidFill>
-                      <a:srgbClr val="404040"/>
-                    </a:solidFill>
-                    <a:latin typeface="Arial"/>
-                  </a:defRPr>
-                </a:pPr>
-              </a:p>
-            </c:txPr>
-            <c:showLegendKey val="0"/>
-            <c:showVal val="1"/>
-            <c:showCatName val="0"/>
-            <c:showSerName val="0"/>
-            <c:showPercent val="0"/>
-            <c:showBubbleSize val="0"/>
-            <c:showLeaderLines val="0"/>
-          </c:dLbls>
-          <c:cat>
-            <c:multiLvlStrRef>
-              <c:f>Sheet1!$A$2:$A$13</c:f>
-              <c:multiLvlStrCache>
-                <c:ptCount val="12"/>
-                <c:lvl>
-                  <c:pt idx="0">
-                    <c:v>Moselle (LU, DE)</c:v>
-                  </c:pt>
-                  <c:pt idx="1">
-                    <c:v>Pyrénées-Orientales (ES, AD)</c:v>
-                  </c:pt>
-                  <c:pt idx="2">
-                    <c:v>Meurthe-et-Moselle (BE, LU)</c:v>
-                  </c:pt>
-                  <c:pt idx="3">
-                    <c:v>Haut-Rhin (DE, CH)</c:v>
-                  </c:pt>
-                  <c:pt idx="4">
-                    <c:v>Haute-Savoie (CH, IT)</c:v>
-                  </c:pt>
-                  <c:pt idx="5">
-                    <c:v>Pyrénées-Atlantiques (ES)</c:v>
-                  </c:pt>
-                  <c:pt idx="6">
-                    <c:v>Bas-Rhin (DE)</c:v>
-                  </c:pt>
-                  <c:pt idx="7">
-                    <c:v>Ardennes (BE)</c:v>
-                  </c:pt>
-                  <c:pt idx="8">
-                    <c:v>Nord (BE)</c:v>
-                  </c:pt>
-                  <c:pt idx="9">
-                    <c:v>Ain (CH)</c:v>
-                  </c:pt>
-                  <c:pt idx="10">
-                    <c:v>Alpes-Maritimes (IT, MC)</c:v>
-                  </c:pt>
-                  <c:pt idx="11">
-                    <c:v>Ariège (ES, AD)</c:v>
-                  </c:pt>
-                </c:lvl>
-              </c:multiLvlStrCache>
-            </c:multiLvlStrRef>
-          </c:cat>
-          <c:val>
-            <c:numRef>
-              <c:f>Sheet1!$B$2:$B$13</c:f>
-              <c:numCache>
-                <c:formatCode>General</c:formatCode>
-                <c:ptCount val="12"/>
-                <c:pt idx="0">
-                  <c:v>13.9</c:v>
-                </c:pt>
-                <c:pt idx="1">
-                  <c:v>12</c:v>
-                </c:pt>
-                <c:pt idx="2">
-                  <c:v>9.5</c:v>
-                </c:pt>
-                <c:pt idx="3">
-                  <c:v>8.8</c:v>
-                </c:pt>
-                <c:pt idx="4">
-                  <c:v>8.7</c:v>
-                </c:pt>
-                <c:pt idx="5">
-                  <c:v>8.4</c:v>
-                </c:pt>
-                <c:pt idx="6">
-                  <c:v>7.8</c:v>
-                </c:pt>
-                <c:pt idx="7">
-                  <c:v>7.7</c:v>
-                </c:pt>
-                <c:pt idx="8">
-                  <c:v>7</c:v>
-                </c:pt>
-                <c:pt idx="9">
-                  <c:v>7</c:v>
-                </c:pt>
-                <c:pt idx="10">
-                  <c:v>6.4</c:v>
-                </c:pt>
-                <c:pt idx="11">
-                  <c:v>5.9</c:v>
-                </c:pt>
-              </c:numCache>
-            </c:numRef>
-          </c:val>
-        </c:ser>
-        <c:dLbls>
-          <c:numFmt formatCode="0.0" sourceLinked="0"/>
-          <c:txPr>
-            <a:bodyPr/>
-            <a:lstStyle/>
-            <a:p>
-              <a:pPr>
-                <a:defRPr b="1" i="0" strike="noStrike" sz="1000" u="none">
-                  <a:solidFill>
-                    <a:srgbClr val="404040"/>
-                  </a:solidFill>
-                  <a:latin typeface="Arial"/>
-                </a:defRPr>
-              </a:pPr>
-            </a:p>
-          </c:txPr>
-          <c:showLegendKey val="0"/>
-          <c:showVal val="1"/>
-          <c:showCatName val="0"/>
-          <c:showSerName val="0"/>
-          <c:showPercent val="0"/>
-          <c:showBubbleSize val="0"/>
-          <c:showLeaderLines val="0"/>
-        </c:dLbls>
-        <c:gapWidth val="35"/>
-        <c:overlap val="0"/>
-        <c:axId val="2094734554"/>
-        <c:axId val="2094734552"/>
-        <c:axId val="2094734556"/>
-      </c:barChart>
-      <c:catAx>
-        <c:axId val="2094734554"/>
-        <c:scaling>
-          <c:orientation val="maxMin"/>
-        </c:scaling>
-        <c:delete val="0"/>
-        <c:axPos val="l"/>
-        <c:numFmt formatCode="General" sourceLinked="1"/>
-        <c:majorTickMark val="out"/>
-        <c:minorTickMark val="none"/>
-        <c:tickLblPos val="nextTo"/>
-        <c:spPr>
-          <a:ln w="12700" cap="flat">
-            <a:solidFill>
-              <a:srgbClr val="888888"/>
-            </a:solidFill>
-            <a:prstDash val="solid"/>
-            <a:round/>
-          </a:ln>
-        </c:spPr>
-        <c:txPr>
-          <a:bodyPr/>
-          <a:lstStyle/>
-          <a:p>
-            <a:pPr>
-              <a:defRPr sz="1000" b="0" i="0" u="none" strike="noStrike">
-                <a:solidFill>
-                  <a:srgbClr val="404040"/>
-                </a:solidFill>
-                <a:latin typeface="Aptos"/>
-              </a:defRPr>
-            </a:pPr>
-            <a:endParaRPr lang="en-US"/>
-          </a:p>
-        </c:txPr>
-        <c:crossAx val="2094734552"/>
-        <c:crosses val="autoZero"/>
-        <c:auto val="1"/>
-        <c:lblAlgn val="ctr"/>
-        <c:noMultiLvlLbl val="1"/>
-      </c:catAx>
-      <c:valAx>
-        <c:axId val="2094734552"/>
-        <c:scaling>
-          <c:orientation val="minMax"/>
-          <c:max val="16"/>
-          <c:min val="0"/>
-        </c:scaling>
-        <c:delete val="1"/>
-        <c:axPos val="b"/>
-        <c:numFmt formatCode="General" sourceLinked="0"/>
-        <c:majorTickMark val="out"/>
-        <c:minorTickMark val="none"/>
-        <c:tickLblPos val="low"/>
-        <c:spPr>
-          <a:ln w="12700" cap="flat">
-            <a:solidFill>
-              <a:srgbClr val="888888"/>
-            </a:solidFill>
-            <a:prstDash val="solid"/>
-            <a:round/>
-          </a:ln>
-        </c:spPr>
-        <c:txPr>
-          <a:bodyPr/>
-          <a:lstStyle/>
-          <a:p>
-            <a:pPr>
-              <a:defRPr sz="1200" b="0" i="0" u="none" strike="noStrike">
-                <a:solidFill>
-                  <a:srgbClr val="000000"/>
-                </a:solidFill>
-                <a:latin typeface="Arial"/>
-              </a:defRPr>
-            </a:pPr>
-            <a:endParaRPr lang="en-US"/>
-          </a:p>
-        </c:txPr>
-        <c:crossAx val="2094734554"/>
-        <c:crosses val="autoZero"/>
-        <c:crossBetween val="between"/>
-      </c:valAx>
-      <c:spPr>
-        <a:noFill/>
-        <a:ln>
-          <a:noFill/>
-        </a:ln>
-        <a:effectLst/>
-      </c:spPr>
-    </c:plotArea>
-    <c:plotVisOnly val="1"/>
-    <c:dispBlanksAs val="span"/>
-  </c:chart>
-  <c:spPr>
-    <a:noFill/>
-    <a:ln>
-      <a:noFill/>
-    </a:ln>
-    <a:effectLst/>
-  </c:spPr>
-  <c:externalData r:id="rId1">
-    <c:autoUpdate val="0"/>
-  </c:externalData>
-</c:chartSpace>
-</file>
-
-<file path=ppt/charts/chart5.xml><?xml version="1.0" encoding="utf-8"?>
 <c:chartSpace xmlns:c="http://schemas.openxmlformats.org/drawingml/2006/chart" xmlns:a="http://schemas.openxmlformats.org/drawingml/2006/main" xmlns:r="http://schemas.openxmlformats.org/officeDocument/2006/relationships">
   <c:date1904 val="0"/>
   <c:roundedCorners val="1"/>
@@ -6198,7 +5913,7 @@
         </p:nvSpPr>
         <p:spPr>
           <a:xfrm>
-            <a:off x="365760" y="1051560"/>
+            <a:off x="365760" y="1005840"/>
             <a:ext cx="7132320" cy="365760"/>
           </a:xfrm>
           <a:prstGeom prst="rect">
@@ -6223,31 +5938,359 @@
                 <a:ea typeface="Aptos" pitchFamily="34" charset="-122"/>
                 <a:cs typeface="Aptos" pitchFamily="34" charset="-120"/>
               </a:rPr>
-              <a:t>Part des dépenses par carte en magasin réalisée dans un pays voisin, 2024 (%, 12 premiers départements)</a:t>
+              <a:t>Part des achats physiques par carte réalisés dans un pays voisin, par département, 2024 (%)</a:t>
             </a:r>
             <a:endParaRPr lang="en-US" sz="1200" dirty="0"/>
           </a:p>
         </p:txBody>
       </p:sp>
-      <p:graphicFrame>
-        <p:nvGraphicFramePr>
-          <p:cNvPr id="7" name="Chart 0" descr=""/>
-          <p:cNvGraphicFramePr/>
-          <p:nvPr/>
-        </p:nvGraphicFramePr>
-        <p:xfrm>
-          <a:off x="274320" y="1463040"/>
-          <a:ext cx="7132320" cy="4434840"/>
-        </p:xfrm>
-        <a:graphic xmlns:a="http://schemas.openxmlformats.org/drawingml/2006/main">
-          <a:graphicData uri="http://schemas.openxmlformats.org/drawingml/2006/chart">
-            <c:chart xmlns:c="http://schemas.openxmlformats.org/drawingml/2006/chart" r:id="rId1"/>
-          </a:graphicData>
-        </a:graphic>
-      </p:graphicFrame>
+      <p:pic>
+        <p:nvPicPr>
+          <p:cNvPr id="7" name="Image 0" descr="Carte de France par département : part des achats par carte réalisés dans un pays voisin en 2024, de moins de 3 % à l'intérieur jusqu'à 13,9 % en Moselle et 12 % dans les Pyrénées-Orientales">    </p:cNvPr>
+          <p:cNvPicPr>
+            <a:picLocks noChangeAspect="1"/>
+          </p:cNvPicPr>
+          <p:nvPr/>
+        </p:nvPicPr>
+        <p:blipFill>
+          <a:blip r:embed="rId1"/>
+          <a:stretch>
+            <a:fillRect/>
+          </a:stretch>
+        </p:blipFill>
+        <p:spPr>
+          <a:xfrm>
+            <a:off x="1468101" y="1371600"/>
+            <a:ext cx="4836198" cy="4206240"/>
+          </a:xfrm>
+          <a:prstGeom prst="rect">
+            <a:avLst/>
+          </a:prstGeom>
+        </p:spPr>
+      </p:pic>
       <p:sp>
         <p:nvSpPr>
           <p:cNvPr id="8" name="Shape 5"/>
+          <p:cNvSpPr/>
+          <p:nvPr/>
+        </p:nvSpPr>
+        <p:spPr>
+          <a:xfrm>
+            <a:off x="411480" y="5687568"/>
+            <a:ext cx="201168" cy="164592"/>
+          </a:xfrm>
+          <a:prstGeom prst="rect">
+            <a:avLst/>
+          </a:prstGeom>
+          <a:solidFill>
+            <a:srgbClr val="8B0F14"/>
+          </a:solidFill>
+          <a:ln w="6350">
+            <a:solidFill>
+              <a:srgbClr val="B4BCC6"/>
+            </a:solidFill>
+            <a:prstDash val="solid"/>
+          </a:ln>
+        </p:spPr>
+      </p:sp>
+      <p:sp>
+        <p:nvSpPr>
+          <p:cNvPr id="9" name="Text 6"/>
+          <p:cNvSpPr txBox="1"/>
+          <p:nvPr/>
+        </p:nvSpPr>
+        <p:spPr>
+          <a:xfrm>
+            <a:off x="667512" y="5650992"/>
+            <a:ext cx="1143000" cy="237744"/>
+          </a:xfrm>
+          <a:prstGeom prst="rect">
+            <a:avLst/>
+          </a:prstGeom>
+          <a:noFill/>
+          <a:ln/>
+        </p:spPr>
+        <p:txBody>
+          <a:bodyPr wrap="square" lIns="0" tIns="0" rIns="0" bIns="0" rtlCol="0" anchor="ctr"/>
+          <a:lstStyle/>
+          <a:p>
+            <a:pPr indent="0" marL="0">
+              <a:buNone/>
+            </a:pPr>
+            <a:r>
+              <a:rPr lang="en-US" sz="1000" dirty="0">
+                <a:solidFill>
+                  <a:srgbClr val="404040"/>
+                </a:solidFill>
+                <a:latin typeface="Aptos" pitchFamily="34" charset="0"/>
+                <a:ea typeface="Aptos" pitchFamily="34" charset="-122"/>
+                <a:cs typeface="Aptos" pitchFamily="34" charset="-120"/>
+              </a:rPr>
+              <a:t>9 % ou plus</a:t>
+            </a:r>
+            <a:endParaRPr lang="en-US" sz="1000" dirty="0"/>
+          </a:p>
+        </p:txBody>
+      </p:sp>
+      <p:sp>
+        <p:nvSpPr>
+          <p:cNvPr id="10" name="Shape 7"/>
+          <p:cNvSpPr/>
+          <p:nvPr/>
+        </p:nvSpPr>
+        <p:spPr>
+          <a:xfrm>
+            <a:off x="1828800" y="5687568"/>
+            <a:ext cx="201168" cy="164592"/>
+          </a:xfrm>
+          <a:prstGeom prst="rect">
+            <a:avLst/>
+          </a:prstGeom>
+          <a:solidFill>
+            <a:srgbClr val="D7301F"/>
+          </a:solidFill>
+          <a:ln w="6350">
+            <a:solidFill>
+              <a:srgbClr val="B4BCC6"/>
+            </a:solidFill>
+            <a:prstDash val="solid"/>
+          </a:ln>
+        </p:spPr>
+      </p:sp>
+      <p:sp>
+        <p:nvSpPr>
+          <p:cNvPr id="11" name="Text 8"/>
+          <p:cNvSpPr txBox="1"/>
+          <p:nvPr/>
+        </p:nvSpPr>
+        <p:spPr>
+          <a:xfrm>
+            <a:off x="2084832" y="5650992"/>
+            <a:ext cx="1143000" cy="237744"/>
+          </a:xfrm>
+          <a:prstGeom prst="rect">
+            <a:avLst/>
+          </a:prstGeom>
+          <a:noFill/>
+          <a:ln/>
+        </p:spPr>
+        <p:txBody>
+          <a:bodyPr wrap="square" lIns="0" tIns="0" rIns="0" bIns="0" rtlCol="0" anchor="ctr"/>
+          <a:lstStyle/>
+          <a:p>
+            <a:pPr indent="0" marL="0">
+              <a:buNone/>
+            </a:pPr>
+            <a:r>
+              <a:rPr lang="en-US" sz="1000" dirty="0">
+                <a:solidFill>
+                  <a:srgbClr val="404040"/>
+                </a:solidFill>
+                <a:latin typeface="Aptos" pitchFamily="34" charset="0"/>
+                <a:ea typeface="Aptos" pitchFamily="34" charset="-122"/>
+                <a:cs typeface="Aptos" pitchFamily="34" charset="-120"/>
+              </a:rPr>
+              <a:t>6 à moins de 9 %</a:t>
+            </a:r>
+            <a:endParaRPr lang="en-US" sz="1000" dirty="0"/>
+          </a:p>
+        </p:txBody>
+      </p:sp>
+      <p:sp>
+        <p:nvSpPr>
+          <p:cNvPr id="12" name="Shape 9"/>
+          <p:cNvSpPr/>
+          <p:nvPr/>
+        </p:nvSpPr>
+        <p:spPr>
+          <a:xfrm>
+            <a:off x="3246120" y="5687568"/>
+            <a:ext cx="201168" cy="164592"/>
+          </a:xfrm>
+          <a:prstGeom prst="rect">
+            <a:avLst/>
+          </a:prstGeom>
+          <a:solidFill>
+            <a:srgbClr val="F39C8B"/>
+          </a:solidFill>
+          <a:ln w="6350">
+            <a:solidFill>
+              <a:srgbClr val="B4BCC6"/>
+            </a:solidFill>
+            <a:prstDash val="solid"/>
+          </a:ln>
+        </p:spPr>
+      </p:sp>
+      <p:sp>
+        <p:nvSpPr>
+          <p:cNvPr id="13" name="Text 10"/>
+          <p:cNvSpPr txBox="1"/>
+          <p:nvPr/>
+        </p:nvSpPr>
+        <p:spPr>
+          <a:xfrm>
+            <a:off x="3502152" y="5650992"/>
+            <a:ext cx="1143000" cy="237744"/>
+          </a:xfrm>
+          <a:prstGeom prst="rect">
+            <a:avLst/>
+          </a:prstGeom>
+          <a:noFill/>
+          <a:ln/>
+        </p:spPr>
+        <p:txBody>
+          <a:bodyPr wrap="square" lIns="0" tIns="0" rIns="0" bIns="0" rtlCol="0" anchor="ctr"/>
+          <a:lstStyle/>
+          <a:p>
+            <a:pPr indent="0" marL="0">
+              <a:buNone/>
+            </a:pPr>
+            <a:r>
+              <a:rPr lang="en-US" sz="1000" dirty="0">
+                <a:solidFill>
+                  <a:srgbClr val="404040"/>
+                </a:solidFill>
+                <a:latin typeface="Aptos" pitchFamily="34" charset="0"/>
+                <a:ea typeface="Aptos" pitchFamily="34" charset="-122"/>
+                <a:cs typeface="Aptos" pitchFamily="34" charset="-120"/>
+              </a:rPr>
+              <a:t>3 à moins de 6 %</a:t>
+            </a:r>
+            <a:endParaRPr lang="en-US" sz="1000" dirty="0"/>
+          </a:p>
+        </p:txBody>
+      </p:sp>
+      <p:sp>
+        <p:nvSpPr>
+          <p:cNvPr id="14" name="Shape 11"/>
+          <p:cNvSpPr/>
+          <p:nvPr/>
+        </p:nvSpPr>
+        <p:spPr>
+          <a:xfrm>
+            <a:off x="4663440" y="5687568"/>
+            <a:ext cx="201168" cy="164592"/>
+          </a:xfrm>
+          <a:prstGeom prst="rect">
+            <a:avLst/>
+          </a:prstGeom>
+          <a:solidFill>
+            <a:srgbClr val="FBE3DC"/>
+          </a:solidFill>
+          <a:ln w="6350">
+            <a:solidFill>
+              <a:srgbClr val="B4BCC6"/>
+            </a:solidFill>
+            <a:prstDash val="solid"/>
+          </a:ln>
+        </p:spPr>
+      </p:sp>
+      <p:sp>
+        <p:nvSpPr>
+          <p:cNvPr id="15" name="Text 12"/>
+          <p:cNvSpPr txBox="1"/>
+          <p:nvPr/>
+        </p:nvSpPr>
+        <p:spPr>
+          <a:xfrm>
+            <a:off x="4919472" y="5650992"/>
+            <a:ext cx="1143000" cy="237744"/>
+          </a:xfrm>
+          <a:prstGeom prst="rect">
+            <a:avLst/>
+          </a:prstGeom>
+          <a:noFill/>
+          <a:ln/>
+        </p:spPr>
+        <p:txBody>
+          <a:bodyPr wrap="square" lIns="0" tIns="0" rIns="0" bIns="0" rtlCol="0" anchor="ctr"/>
+          <a:lstStyle/>
+          <a:p>
+            <a:pPr indent="0" marL="0">
+              <a:buNone/>
+            </a:pPr>
+            <a:r>
+              <a:rPr lang="en-US" sz="1000" dirty="0">
+                <a:solidFill>
+                  <a:srgbClr val="404040"/>
+                </a:solidFill>
+                <a:latin typeface="Aptos" pitchFamily="34" charset="0"/>
+                <a:ea typeface="Aptos" pitchFamily="34" charset="-122"/>
+                <a:cs typeface="Aptos" pitchFamily="34" charset="-120"/>
+              </a:rPr>
+              <a:t>Moins de 3 %</a:t>
+            </a:r>
+            <a:endParaRPr lang="en-US" sz="1000" dirty="0"/>
+          </a:p>
+        </p:txBody>
+      </p:sp>
+      <p:sp>
+        <p:nvSpPr>
+          <p:cNvPr id="16" name="Shape 13"/>
+          <p:cNvSpPr/>
+          <p:nvPr/>
+        </p:nvSpPr>
+        <p:spPr>
+          <a:xfrm>
+            <a:off x="6080760" y="5687568"/>
+            <a:ext cx="201168" cy="164592"/>
+          </a:xfrm>
+          <a:prstGeom prst="rect">
+            <a:avLst/>
+          </a:prstGeom>
+          <a:solidFill>
+            <a:srgbClr val="C8C8C8"/>
+          </a:solidFill>
+          <a:ln w="6350">
+            <a:solidFill>
+              <a:srgbClr val="B4BCC6"/>
+            </a:solidFill>
+            <a:prstDash val="solid"/>
+          </a:ln>
+        </p:spPr>
+      </p:sp>
+      <p:sp>
+        <p:nvSpPr>
+          <p:cNvPr id="17" name="Text 14"/>
+          <p:cNvSpPr txBox="1"/>
+          <p:nvPr/>
+        </p:nvSpPr>
+        <p:spPr>
+          <a:xfrm>
+            <a:off x="6336792" y="5650992"/>
+            <a:ext cx="1143000" cy="237744"/>
+          </a:xfrm>
+          <a:prstGeom prst="rect">
+            <a:avLst/>
+          </a:prstGeom>
+          <a:noFill/>
+          <a:ln/>
+        </p:spPr>
+        <p:txBody>
+          <a:bodyPr wrap="square" lIns="0" tIns="0" rIns="0" bIns="0" rtlCol="0" anchor="ctr"/>
+          <a:lstStyle/>
+          <a:p>
+            <a:pPr indent="0" marL="0">
+              <a:buNone/>
+            </a:pPr>
+            <a:r>
+              <a:rPr lang="en-US" sz="1000" dirty="0">
+                <a:solidFill>
+                  <a:srgbClr val="404040"/>
+                </a:solidFill>
+                <a:latin typeface="Aptos" pitchFamily="34" charset="0"/>
+                <a:ea typeface="Aptos" pitchFamily="34" charset="-122"/>
+                <a:cs typeface="Aptos" pitchFamily="34" charset="-120"/>
+              </a:rPr>
+              <a:t>Non disponible</a:t>
+            </a:r>
+            <a:endParaRPr lang="en-US" sz="1000" dirty="0"/>
+          </a:p>
+        </p:txBody>
+      </p:sp>
+      <p:sp>
+        <p:nvSpPr>
+          <p:cNvPr id="18" name="Shape 15"/>
           <p:cNvSpPr/>
           <p:nvPr/>
         </p:nvSpPr>
@@ -6272,7 +6315,7 @@
       </p:sp>
       <p:sp>
         <p:nvSpPr>
-          <p:cNvPr id="9" name="Text 6"/>
+          <p:cNvPr id="19" name="Text 16"/>
           <p:cNvSpPr txBox="1"/>
           <p:nvPr/>
         </p:nvSpPr>
@@ -6311,7 +6354,7 @@
       </p:sp>
       <p:sp>
         <p:nvSpPr>
-          <p:cNvPr id="10" name="Text 7"/>
+          <p:cNvPr id="20" name="Text 17"/>
           <p:cNvSpPr txBox="1"/>
           <p:nvPr/>
         </p:nvSpPr>
@@ -6350,7 +6393,7 @@
       </p:sp>
       <p:sp>
         <p:nvSpPr>
-          <p:cNvPr id="11" name="Shape 8"/>
+          <p:cNvPr id="21" name="Shape 18"/>
           <p:cNvSpPr/>
           <p:nvPr/>
         </p:nvSpPr>
@@ -6375,7 +6418,7 @@
       </p:sp>
       <p:sp>
         <p:nvSpPr>
-          <p:cNvPr id="12" name="Text 9"/>
+          <p:cNvPr id="22" name="Text 19"/>
           <p:cNvSpPr txBox="1"/>
           <p:nvPr/>
         </p:nvSpPr>
@@ -6414,7 +6457,7 @@
       </p:sp>
       <p:sp>
         <p:nvSpPr>
-          <p:cNvPr id="13" name="Text 10"/>
+          <p:cNvPr id="23" name="Text 20"/>
           <p:cNvSpPr txBox="1"/>
           <p:nvPr/>
         </p:nvSpPr>
@@ -6453,7 +6496,7 @@
       </p:sp>
       <p:sp>
         <p:nvSpPr>
-          <p:cNvPr id="14" name="Text 11"/>
+          <p:cNvPr id="24" name="Text 21"/>
           <p:cNvSpPr txBox="1"/>
           <p:nvPr/>
         </p:nvSpPr>
@@ -6589,7 +6632,7 @@
       </p:sp>
       <p:sp>
         <p:nvSpPr>
-          <p:cNvPr id="15" name="Text 12"/>
+          <p:cNvPr id="25" name="Text 22"/>
           <p:cNvSpPr txBox="1"/>
           <p:nvPr/>
         </p:nvSpPr>

</xml_diff>